<commit_message>
Add phase 2 query intelligence
</commit_message>
<xml_diff>
--- a/docs/Financial_Intelligence_Engine_Phase2_Review1_Mentor_Update.pptx
+++ b/docs/Financial_Intelligence_Engine_Phase2_Review1_Mentor_Update.pptx
@@ -2,30 +2,31 @@
 <file path=ppt/presentation.xml><?xml version="1.0" encoding="utf-8"?>
 <p:presentation xmlns:p="http://schemas.openxmlformats.org/presentationml/2006/main">
   <p:sldMasterIdLst>
-    <p:sldMasterId xmlns:r="http://schemas.openxmlformats.org/officeDocument/2006/relationships" id="2147483648" r:id="R140831e0907c4eec"/>
+    <p:sldMasterId xmlns:r="http://schemas.openxmlformats.org/officeDocument/2006/relationships" id="2147483648" r:id="R6c57dbe4759748d8"/>
   </p:sldMasterIdLst>
   <p:notesMasterIdLst>
-    <p:notesMasterId xmlns:r="http://schemas.openxmlformats.org/officeDocument/2006/relationships" r:id="Rd0b791d995f04671"/>
+    <p:notesMasterId xmlns:r="http://schemas.openxmlformats.org/officeDocument/2006/relationships" r:id="R47719a2b95ea40d4"/>
   </p:notesMasterIdLst>
   <p:sldIdLst>
-    <p:sldId xmlns:r="http://schemas.openxmlformats.org/officeDocument/2006/relationships" id="256" r:id="Rb1c862c868704818"/>
-    <p:sldId xmlns:r="http://schemas.openxmlformats.org/officeDocument/2006/relationships" id="257" r:id="Rccd720b687b34516"/>
-    <p:sldId xmlns:r="http://schemas.openxmlformats.org/officeDocument/2006/relationships" id="258" r:id="Rf4c65a5d05e94fe8"/>
-    <p:sldId xmlns:r="http://schemas.openxmlformats.org/officeDocument/2006/relationships" id="259" r:id="R6a6189c9d413441e"/>
-    <p:sldId xmlns:r="http://schemas.openxmlformats.org/officeDocument/2006/relationships" id="260" r:id="R88cecfd7bbb5416b"/>
-    <p:sldId xmlns:r="http://schemas.openxmlformats.org/officeDocument/2006/relationships" id="261" r:id="R3a8860a7f74445c9"/>
-    <p:sldId xmlns:r="http://schemas.openxmlformats.org/officeDocument/2006/relationships" id="262" r:id="R54e24291603448a7"/>
-    <p:sldId xmlns:r="http://schemas.openxmlformats.org/officeDocument/2006/relationships" id="263" r:id="R1769519032f4486b"/>
-    <p:sldId xmlns:r="http://schemas.openxmlformats.org/officeDocument/2006/relationships" id="264" r:id="R1efb29bdf4ef4c6d"/>
-    <p:sldId xmlns:r="http://schemas.openxmlformats.org/officeDocument/2006/relationships" id="265" r:id="Ra872bd8de8a24d33"/>
-    <p:sldId xmlns:r="http://schemas.openxmlformats.org/officeDocument/2006/relationships" id="266" r:id="R0884329a52a740a2"/>
-    <p:sldId xmlns:r="http://schemas.openxmlformats.org/officeDocument/2006/relationships" id="267" r:id="R9b5c0e0e5f18490a"/>
-    <p:sldId xmlns:r="http://schemas.openxmlformats.org/officeDocument/2006/relationships" id="268" r:id="Rd45b29d32aa04d85"/>
-    <p:sldId xmlns:r="http://schemas.openxmlformats.org/officeDocument/2006/relationships" id="269" r:id="R0dd50094dc034bfc"/>
-    <p:sldId xmlns:r="http://schemas.openxmlformats.org/officeDocument/2006/relationships" id="270" r:id="R00e281437b754c31"/>
-    <p:sldId xmlns:r="http://schemas.openxmlformats.org/officeDocument/2006/relationships" id="271" r:id="R1be9aee060b2403b"/>
-    <p:sldId xmlns:r="http://schemas.openxmlformats.org/officeDocument/2006/relationships" id="272" r:id="R33bf4f37fd0c412c"/>
-    <p:sldId xmlns:r="http://schemas.openxmlformats.org/officeDocument/2006/relationships" id="273" r:id="Rbe8beab26573442e"/>
+    <p:sldId xmlns:r="http://schemas.openxmlformats.org/officeDocument/2006/relationships" id="256" r:id="Rdba891d6c6b84991"/>
+    <p:sldId xmlns:r="http://schemas.openxmlformats.org/officeDocument/2006/relationships" id="257" r:id="R3c14e1be169a4361"/>
+    <p:sldId xmlns:r="http://schemas.openxmlformats.org/officeDocument/2006/relationships" id="258" r:id="R6bfee4c1d63d461f"/>
+    <p:sldId xmlns:r="http://schemas.openxmlformats.org/officeDocument/2006/relationships" id="259" r:id="R5175900f890a4843"/>
+    <p:sldId xmlns:r="http://schemas.openxmlformats.org/officeDocument/2006/relationships" id="260" r:id="Re0cd0baad92c4023"/>
+    <p:sldId xmlns:r="http://schemas.openxmlformats.org/officeDocument/2006/relationships" id="261" r:id="Re0084be1fc0448f1"/>
+    <p:sldId xmlns:r="http://schemas.openxmlformats.org/officeDocument/2006/relationships" id="262" r:id="R8622ba03f2fa457a"/>
+    <p:sldId xmlns:r="http://schemas.openxmlformats.org/officeDocument/2006/relationships" id="263" r:id="R4eb88cfc8b9447b0"/>
+    <p:sldId xmlns:r="http://schemas.openxmlformats.org/officeDocument/2006/relationships" id="264" r:id="R1661dc892969444f"/>
+    <p:sldId xmlns:r="http://schemas.openxmlformats.org/officeDocument/2006/relationships" id="265" r:id="Rb2d47ed3ecf14199"/>
+    <p:sldId xmlns:r="http://schemas.openxmlformats.org/officeDocument/2006/relationships" id="266" r:id="R4920effccdd1499c"/>
+    <p:sldId xmlns:r="http://schemas.openxmlformats.org/officeDocument/2006/relationships" id="267" r:id="Rd93fdac9c92c4352"/>
+    <p:sldId xmlns:r="http://schemas.openxmlformats.org/officeDocument/2006/relationships" id="268" r:id="Rd532c18d4d2846b5"/>
+    <p:sldId xmlns:r="http://schemas.openxmlformats.org/officeDocument/2006/relationships" id="269" r:id="R7e261990f24541b8"/>
+    <p:sldId xmlns:r="http://schemas.openxmlformats.org/officeDocument/2006/relationships" id="270" r:id="R54f690a5e0b54d14"/>
+    <p:sldId xmlns:r="http://schemas.openxmlformats.org/officeDocument/2006/relationships" id="271" r:id="Rcd90bd7bd10c4188"/>
+    <p:sldId xmlns:r="http://schemas.openxmlformats.org/officeDocument/2006/relationships" id="272" r:id="Rdd6258fe0375433e"/>
+    <p:sldId xmlns:r="http://schemas.openxmlformats.org/officeDocument/2006/relationships" id="273" r:id="R33495775323a4c8a"/>
+    <p:sldId xmlns:r="http://schemas.openxmlformats.org/officeDocument/2006/relationships" id="274" r:id="R1b4dc52cf811453e"/>
   </p:sldIdLst>
   <p:sldSz cx="12192000" cy="6858000"/>
   <p:notesSz cx="6858000" cy="9144000"/>
@@ -1161,6 +1162,72 @@
 </p:notes>
 </file>
 
+<file path=ppt/notesSlides/notesSlide19.xml><?xml version="1.0" encoding="utf-8"?>
+<p:notes xmlns:p="http://schemas.openxmlformats.org/presentationml/2006/main">
+  <p:cSld>
+    <p:spTree>
+      <p:nvGrpSpPr>
+        <p:cNvPr id="1" name=""/>
+        <p:cNvGrpSpPr/>
+        <p:nvPr/>
+      </p:nvGrpSpPr>
+      <p:grpSpPr>
+        <a:xfrm xmlns:a="http://schemas.openxmlformats.org/drawingml/2006/main"/>
+      </p:grpSpPr>
+      <p:sp>
+        <p:nvSpPr>
+          <p:cNvPr id="2" name="Slide Image Placeholder 1"/>
+          <p:cNvSpPr>
+            <a:spLocks xmlns:a="http://schemas.openxmlformats.org/drawingml/2006/main" noGrp="1"/>
+          </p:cNvSpPr>
+          <p:nvPr>
+            <p:ph type="sldImg" idx="0"/>
+          </p:nvPr>
+        </p:nvSpPr>
+        <p:spPr/>
+      </p:sp>
+      <p:sp>
+        <p:nvSpPr>
+          <p:cNvPr id="3" name="Notes Placeholder 2"/>
+          <p:cNvSpPr>
+            <a:spLocks xmlns:a="http://schemas.openxmlformats.org/drawingml/2006/main" noGrp="1"/>
+          </p:cNvSpPr>
+          <p:nvPr>
+            <p:ph type="body" idx="1"/>
+          </p:nvPr>
+        </p:nvSpPr>
+        <p:spPr/>
+        <p:txBody>
+          <a:bodyPr xmlns:a="http://schemas.openxmlformats.org/drawingml/2006/main"/>
+          <a:lstStyle xmlns:a="http://schemas.openxmlformats.org/drawingml/2006/main"/>
+          <a:p xmlns:a="http://schemas.openxmlformats.org/drawingml/2006/main"/>
+        </p:txBody>
+      </p:sp>
+      <p:sp>
+        <p:nvSpPr>
+          <p:cNvPr id="4" name="Slide Number Placeholder 3"/>
+          <p:cNvSpPr>
+            <a:spLocks xmlns:a="http://schemas.openxmlformats.org/drawingml/2006/main" noGrp="1"/>
+          </p:cNvSpPr>
+          <p:nvPr>
+            <p:ph type="sldNum" idx="5"/>
+          </p:nvPr>
+        </p:nvSpPr>
+        <p:spPr/>
+        <p:txBody>
+          <a:bodyPr xmlns:a="http://schemas.openxmlformats.org/drawingml/2006/main"/>
+          <a:lstStyle xmlns:a="http://schemas.openxmlformats.org/drawingml/2006/main"/>
+          <a:p xmlns:a="http://schemas.openxmlformats.org/drawingml/2006/main"/>
+        </p:txBody>
+      </p:sp>
+    </p:spTree>
+  </p:cSld>
+  <p:clrMapOvr>
+    <a:masterClrMapping xmlns:a="http://schemas.openxmlformats.org/drawingml/2006/main"/>
+  </p:clrMapOvr>
+</p:notes>
+</file>
+
 <file path=ppt/notesSlides/notesSlide2.xml><?xml version="1.0" encoding="utf-8"?>
 <p:notes xmlns:p="http://schemas.openxmlformats.org/presentationml/2006/main">
   <p:cSld>
@@ -4615,17 +4682,17 @@
   </p:cSld>
   <p:clrMap bg1="lt1" tx1="dk1" bg2="lt2" tx2="dk2" accent1="accent1" accent2="accent2" accent3="accent3" accent4="accent4" accent5="accent5" accent6="accent6" hlink="hlink" folHlink="folHlink"/>
   <p:sldLayoutIdLst>
-    <p:sldLayoutId xmlns:r="http://schemas.openxmlformats.org/officeDocument/2006/relationships" id="2147483649" r:id="R6eb518d0d0944d0e"/>
-    <p:sldLayoutId xmlns:r="http://schemas.openxmlformats.org/officeDocument/2006/relationships" id="2147483650" r:id="R4204e9b3a9854bbf"/>
-    <p:sldLayoutId xmlns:r="http://schemas.openxmlformats.org/officeDocument/2006/relationships" id="2147483651" r:id="R424a65f9607a4977"/>
-    <p:sldLayoutId xmlns:r="http://schemas.openxmlformats.org/officeDocument/2006/relationships" id="2147483652" r:id="R864329e4995348cc"/>
-    <p:sldLayoutId xmlns:r="http://schemas.openxmlformats.org/officeDocument/2006/relationships" id="2147483653" r:id="R82e197cb0bef4a8a"/>
-    <p:sldLayoutId xmlns:r="http://schemas.openxmlformats.org/officeDocument/2006/relationships" id="2147483654" r:id="Rea6faa856ba84bc2"/>
-    <p:sldLayoutId xmlns:r="http://schemas.openxmlformats.org/officeDocument/2006/relationships" id="2147483655" r:id="Ra7bbc8a682754940"/>
-    <p:sldLayoutId xmlns:r="http://schemas.openxmlformats.org/officeDocument/2006/relationships" id="2147483656" r:id="Rc62ad87b1c8f4607"/>
-    <p:sldLayoutId xmlns:r="http://schemas.openxmlformats.org/officeDocument/2006/relationships" id="2147483657" r:id="R86607903d61d4f5f"/>
-    <p:sldLayoutId xmlns:r="http://schemas.openxmlformats.org/officeDocument/2006/relationships" id="2147483658" r:id="R6d1219e88f6241dd"/>
-    <p:sldLayoutId xmlns:r="http://schemas.openxmlformats.org/officeDocument/2006/relationships" id="2147483659" r:id="Rc9d74459b5cb432e"/>
+    <p:sldLayoutId xmlns:r="http://schemas.openxmlformats.org/officeDocument/2006/relationships" id="2147483649" r:id="Rd377b370747b497d"/>
+    <p:sldLayoutId xmlns:r="http://schemas.openxmlformats.org/officeDocument/2006/relationships" id="2147483650" r:id="R9497225123154983"/>
+    <p:sldLayoutId xmlns:r="http://schemas.openxmlformats.org/officeDocument/2006/relationships" id="2147483651" r:id="R3e84247437da4e4a"/>
+    <p:sldLayoutId xmlns:r="http://schemas.openxmlformats.org/officeDocument/2006/relationships" id="2147483652" r:id="R198e07e6d90e4e32"/>
+    <p:sldLayoutId xmlns:r="http://schemas.openxmlformats.org/officeDocument/2006/relationships" id="2147483653" r:id="Ra5fac27ded3f417a"/>
+    <p:sldLayoutId xmlns:r="http://schemas.openxmlformats.org/officeDocument/2006/relationships" id="2147483654" r:id="R61fbd7230cf64351"/>
+    <p:sldLayoutId xmlns:r="http://schemas.openxmlformats.org/officeDocument/2006/relationships" id="2147483655" r:id="R67a60798257e40f9"/>
+    <p:sldLayoutId xmlns:r="http://schemas.openxmlformats.org/officeDocument/2006/relationships" id="2147483656" r:id="R4cbd8919fcfe4e8b"/>
+    <p:sldLayoutId xmlns:r="http://schemas.openxmlformats.org/officeDocument/2006/relationships" id="2147483657" r:id="Rd132172fb06d4e00"/>
+    <p:sldLayoutId xmlns:r="http://schemas.openxmlformats.org/officeDocument/2006/relationships" id="2147483658" r:id="Rb172ea78f8e24d7b"/>
+    <p:sldLayoutId xmlns:r="http://schemas.openxmlformats.org/officeDocument/2006/relationships" id="2147483659" r:id="R7f164f7bea3c422d"/>
   </p:sldLayoutIdLst>
   <p:txStyles>
     <p:titleStyle>
@@ -22341,6 +22408,1933 @@
     <p:extLst>
       <p:ext uri="{BB962C8B-B14F-4D97-AF65-F5344CB8AC3E}">
         <p14:creationId xmlns:p14="http://schemas.microsoft.com/office/powerpoint/2010/main" val="1643650815"/>
+      </p:ext>
+    </p:extLst>
+  </p:cSld>
+</p:sld>
+</file>
+
+<file path=ppt/slides/slide19.xml><?xml version="1.0" encoding="utf-8"?>
+<p:sld xmlns:p="http://schemas.openxmlformats.org/presentationml/2006/main">
+  <p:cSld>
+    <p:bg>
+      <p:bgPr>
+        <a:solidFill xmlns:a="http://schemas.openxmlformats.org/drawingml/2006/main">
+          <a:srgbClr val="F7F8F4"/>
+        </a:solidFill>
+      </p:bgPr>
+    </p:bg>
+    <p:spTree>
+      <p:nvGrpSpPr>
+        <p:cNvPr id="1" name=""/>
+        <p:cNvGrpSpPr/>
+        <p:nvPr/>
+      </p:nvGrpSpPr>
+      <p:grpSpPr>
+        <a:xfrm xmlns:a="http://schemas.openxmlformats.org/drawingml/2006/main"/>
+      </p:grpSpPr>
+      <p:sp>
+        <p:nvSpPr>
+          <p:cNvPr id="2" name="TextBox 1">
+            <a:extLst xmlns:a="http://schemas.openxmlformats.org/drawingml/2006/main">
+              <a:ext uri="{FF2B5EF4-FFF2-40B4-BE49-F238E27FC236}">
+                <a16:creationId xmlns:a16="http://schemas.microsoft.com/office/drawing/2014/main" id="{5E21DD98-8656-47AB-AB3F-161FD785A36F}"/>
+              </a:ext>
+            </a:extLst>
+          </p:cNvPr>
+          <p:cNvSpPr>
+            <a:spLocks xmlns:a="http://schemas.openxmlformats.org/drawingml/2006/main" noGrp="1"/>
+          </p:cNvSpPr>
+          <p:nvPr/>
+        </p:nvSpPr>
+        <p:spPr>
+          <a:xfrm xmlns:a="http://schemas.openxmlformats.org/drawingml/2006/main">
+            <a:off x="502920" y="310896"/>
+            <a:ext cx="4846320" cy="201168"/>
+          </a:xfrm>
+          <a:prstGeom xmlns:a="http://schemas.openxmlformats.org/drawingml/2006/main" prst="rect">
+            <a:avLst/>
+          </a:prstGeom>
+          <a:noFill xmlns:a="http://schemas.openxmlformats.org/drawingml/2006/main"/>
+        </p:spPr>
+        <p:txBody>
+          <a:bodyPr xmlns:a="http://schemas.openxmlformats.org/drawingml/2006/main" wrap="square" lIns="36576" tIns="18288" rIns="36576" bIns="18288" anchor="t">
+            <a:spAutoFit/>
+          </a:bodyPr>
+          <a:lstStyle xmlns:a="http://schemas.openxmlformats.org/drawingml/2006/main"/>
+          <a:p xmlns:a="http://schemas.openxmlformats.org/drawingml/2006/main">
+            <a:r>
+              <a:rPr sz="1000" b="1">
+                <a:solidFill>
+                  <a:srgbClr val="117A65"/>
+                </a:solidFill>
+                <a:latin typeface="Aptos"/>
+                <a:ea typeface="Aptos"/>
+                <a:cs typeface="Aptos"/>
+              </a:rPr>
+              <a:t>QUERY INTELLIGENCE</a:t>
+            </a:r>
+          </a:p>
+        </p:txBody>
+      </p:sp>
+      <p:sp>
+        <p:nvSpPr>
+          <p:cNvPr id="3" name="Rectangle 2">
+            <a:extLst xmlns:a="http://schemas.openxmlformats.org/drawingml/2006/main">
+              <a:ext uri="{FF2B5EF4-FFF2-40B4-BE49-F238E27FC236}">
+                <a16:creationId xmlns:a16="http://schemas.microsoft.com/office/drawing/2014/main" id="{BC04383D-DCC3-40F5-9A0F-0985A2380023}"/>
+              </a:ext>
+            </a:extLst>
+          </p:cNvPr>
+          <p:cNvSpPr>
+            <a:spLocks xmlns:a="http://schemas.openxmlformats.org/drawingml/2006/main" noGrp="1"/>
+          </p:cNvSpPr>
+          <p:nvPr/>
+        </p:nvSpPr>
+        <p:spPr>
+          <a:xfrm xmlns:a="http://schemas.openxmlformats.org/drawingml/2006/main">
+            <a:off x="502920" y="566928"/>
+            <a:ext cx="530352" cy="32004"/>
+          </a:xfrm>
+          <a:prstGeom xmlns:a="http://schemas.openxmlformats.org/drawingml/2006/main" prst="rect">
+            <a:avLst/>
+          </a:prstGeom>
+          <a:solidFill xmlns:a="http://schemas.openxmlformats.org/drawingml/2006/main">
+            <a:srgbClr val="117A65"/>
+          </a:solidFill>
+          <a:ln xmlns:a="http://schemas.openxmlformats.org/drawingml/2006/main">
+            <a:noFill/>
+          </a:ln>
+        </p:spPr>
+        <p:style>
+          <a:lnRef xmlns:a="http://schemas.openxmlformats.org/drawingml/2006/main" idx="1">
+            <a:schemeClr val="accent1"/>
+          </a:lnRef>
+          <a:fillRef xmlns:a="http://schemas.openxmlformats.org/drawingml/2006/main" idx="3">
+            <a:schemeClr val="accent1"/>
+          </a:fillRef>
+          <a:effectRef xmlns:a="http://schemas.openxmlformats.org/drawingml/2006/main" idx="2">
+            <a:schemeClr val="accent1"/>
+          </a:effectRef>
+          <a:fontRef xmlns:a="http://schemas.openxmlformats.org/drawingml/2006/main" idx="minor">
+            <a:schemeClr val="lt1"/>
+          </a:fontRef>
+        </p:style>
+        <p:txBody>
+          <a:bodyPr xmlns:a="http://schemas.openxmlformats.org/drawingml/2006/main" anchor="ctr"/>
+          <a:lstStyle xmlns:a="http://schemas.openxmlformats.org/drawingml/2006/main"/>
+          <a:p xmlns:a="http://schemas.openxmlformats.org/drawingml/2006/main">
+            <a:pPr algn="ctr">
+              <a:buNone/>
+            </a:pPr>
+          </a:p>
+        </p:txBody>
+      </p:sp>
+      <p:sp>
+        <p:nvSpPr>
+          <p:cNvPr id="4" name="TextBox 3">
+            <a:extLst xmlns:a="http://schemas.openxmlformats.org/drawingml/2006/main">
+              <a:ext uri="{FF2B5EF4-FFF2-40B4-BE49-F238E27FC236}">
+                <a16:creationId xmlns:a16="http://schemas.microsoft.com/office/drawing/2014/main" id="{6DC493C6-0AEE-4E74-AA41-621D185E6084}"/>
+              </a:ext>
+            </a:extLst>
+          </p:cNvPr>
+          <p:cNvSpPr>
+            <a:spLocks xmlns:a="http://schemas.openxmlformats.org/drawingml/2006/main" noGrp="1"/>
+          </p:cNvSpPr>
+          <p:nvPr/>
+        </p:nvSpPr>
+        <p:spPr>
+          <a:xfrm xmlns:a="http://schemas.openxmlformats.org/drawingml/2006/main">
+            <a:off x="502920" y="713232"/>
+            <a:ext cx="8046720" cy="467820"/>
+          </a:xfrm>
+          <a:prstGeom xmlns:a="http://schemas.openxmlformats.org/drawingml/2006/main" prst="rect">
+            <a:avLst/>
+          </a:prstGeom>
+          <a:noFill xmlns:a="http://schemas.openxmlformats.org/drawingml/2006/main"/>
+        </p:spPr>
+        <p:txBody>
+          <a:bodyPr xmlns:a="http://schemas.openxmlformats.org/drawingml/2006/main" wrap="square" lIns="36576" tIns="18288" rIns="36576" bIns="18288" anchor="t">
+            <a:spAutoFit/>
+          </a:bodyPr>
+          <a:lstStyle xmlns:a="http://schemas.openxmlformats.org/drawingml/2006/main"/>
+          <a:p xmlns:a="http://schemas.openxmlformats.org/drawingml/2006/main">
+            <a:r>
+              <a:rPr sz="1600" b="1">
+                <a:solidFill>
+                  <a:srgbClr val="122026"/>
+                </a:solidFill>
+                <a:latin typeface="Aptos"/>
+                <a:ea typeface="Aptos"/>
+                <a:cs typeface="Aptos"/>
+              </a:rPr>
+              <a:t>Phase 2 now classifies the user question before the multi-agent workflow runs.</a:t>
+            </a:r>
+          </a:p>
+        </p:txBody>
+      </p:sp>
+      <p:sp>
+        <p:nvSpPr>
+          <p:cNvPr id="5" name="TextBox 4">
+            <a:extLst xmlns:a="http://schemas.openxmlformats.org/drawingml/2006/main">
+              <a:ext uri="{FF2B5EF4-FFF2-40B4-BE49-F238E27FC236}">
+                <a16:creationId xmlns:a16="http://schemas.microsoft.com/office/drawing/2014/main" id="{66BA2416-0044-4138-A197-4E409AC26E3C}"/>
+              </a:ext>
+            </a:extLst>
+          </p:cNvPr>
+          <p:cNvSpPr>
+            <a:spLocks xmlns:a="http://schemas.openxmlformats.org/drawingml/2006/main" noGrp="1"/>
+          </p:cNvSpPr>
+          <p:nvPr/>
+        </p:nvSpPr>
+        <p:spPr>
+          <a:xfrm xmlns:a="http://schemas.openxmlformats.org/drawingml/2006/main">
+            <a:off x="530352" y="1298448"/>
+            <a:ext cx="8046720" cy="417576"/>
+          </a:xfrm>
+          <a:prstGeom xmlns:a="http://schemas.openxmlformats.org/drawingml/2006/main" prst="rect">
+            <a:avLst/>
+          </a:prstGeom>
+          <a:noFill xmlns:a="http://schemas.openxmlformats.org/drawingml/2006/main"/>
+        </p:spPr>
+        <p:txBody>
+          <a:bodyPr xmlns:a="http://schemas.openxmlformats.org/drawingml/2006/main" wrap="square" lIns="36576" tIns="18288" rIns="36576" bIns="18288" anchor="t">
+            <a:spAutoFit/>
+          </a:bodyPr>
+          <a:lstStyle xmlns:a="http://schemas.openxmlformats.org/drawingml/2006/main"/>
+          <a:p xmlns:a="http://schemas.openxmlformats.org/drawingml/2006/main">
+            <a:r>
+              <a:rPr sz="1250" b="0">
+                <a:solidFill>
+                  <a:srgbClr val="5B6970"/>
+                </a:solidFill>
+                <a:latin typeface="Aptos"/>
+                <a:ea typeface="Aptos"/>
+                <a:cs typeface="Aptos"/>
+              </a:rPr>
+              <a:t>The app can detect budget, risk profile, horizon, allocation need, and comparison intent, then route agents with clearer assumptions.</a:t>
+            </a:r>
+          </a:p>
+        </p:txBody>
+      </p:sp>
+      <p:sp>
+        <p:nvSpPr>
+          <p:cNvPr id="6" name="TextBox 5">
+            <a:extLst xmlns:a="http://schemas.openxmlformats.org/drawingml/2006/main">
+              <a:ext uri="{FF2B5EF4-FFF2-40B4-BE49-F238E27FC236}">
+                <a16:creationId xmlns:a16="http://schemas.microsoft.com/office/drawing/2014/main" id="{678992A0-A754-4DAE-BE23-2C3F16E9B1FB}"/>
+              </a:ext>
+            </a:extLst>
+          </p:cNvPr>
+          <p:cNvSpPr>
+            <a:spLocks xmlns:a="http://schemas.openxmlformats.org/drawingml/2006/main" noGrp="1"/>
+          </p:cNvSpPr>
+          <p:nvPr/>
+        </p:nvSpPr>
+        <p:spPr>
+          <a:xfrm xmlns:a="http://schemas.openxmlformats.org/drawingml/2006/main">
+            <a:off x="502920" y="6473952"/>
+            <a:ext cx="4572000" cy="164592"/>
+          </a:xfrm>
+          <a:prstGeom xmlns:a="http://schemas.openxmlformats.org/drawingml/2006/main" prst="rect">
+            <a:avLst/>
+          </a:prstGeom>
+          <a:noFill xmlns:a="http://schemas.openxmlformats.org/drawingml/2006/main"/>
+        </p:spPr>
+        <p:txBody>
+          <a:bodyPr xmlns:a="http://schemas.openxmlformats.org/drawingml/2006/main" wrap="square" lIns="36576" tIns="18288" rIns="36576" bIns="18288" anchor="t">
+            <a:spAutoFit/>
+          </a:bodyPr>
+          <a:lstStyle xmlns:a="http://schemas.openxmlformats.org/drawingml/2006/main"/>
+          <a:p xmlns:a="http://schemas.openxmlformats.org/drawingml/2006/main">
+            <a:r>
+              <a:rPr sz="800" b="0">
+                <a:solidFill>
+                  <a:srgbClr val="5B6970"/>
+                </a:solidFill>
+                <a:latin typeface="Aptos"/>
+                <a:ea typeface="Aptos"/>
+                <a:cs typeface="Aptos"/>
+              </a:rPr>
+              <a:t>Financial Intelligence Engine | Phase 2 progress</a:t>
+            </a:r>
+          </a:p>
+        </p:txBody>
+      </p:sp>
+      <p:sp>
+        <p:nvSpPr>
+          <p:cNvPr id="7" name="TextBox 6">
+            <a:extLst xmlns:a="http://schemas.openxmlformats.org/drawingml/2006/main">
+              <a:ext uri="{FF2B5EF4-FFF2-40B4-BE49-F238E27FC236}">
+                <a16:creationId xmlns:a16="http://schemas.microsoft.com/office/drawing/2014/main" id="{9F5B0C58-17E3-4134-AEA4-1A8C513E4F58}"/>
+              </a:ext>
+            </a:extLst>
+          </p:cNvPr>
+          <p:cNvSpPr>
+            <a:spLocks xmlns:a="http://schemas.openxmlformats.org/drawingml/2006/main" noGrp="1"/>
+          </p:cNvSpPr>
+          <p:nvPr/>
+        </p:nvSpPr>
+        <p:spPr>
+          <a:xfrm xmlns:a="http://schemas.openxmlformats.org/drawingml/2006/main">
+            <a:off x="11283696" y="6473952"/>
+            <a:ext cx="320040" cy="164592"/>
+          </a:xfrm>
+          <a:prstGeom xmlns:a="http://schemas.openxmlformats.org/drawingml/2006/main" prst="rect">
+            <a:avLst/>
+          </a:prstGeom>
+          <a:noFill xmlns:a="http://schemas.openxmlformats.org/drawingml/2006/main"/>
+        </p:spPr>
+        <p:txBody>
+          <a:bodyPr xmlns:a="http://schemas.openxmlformats.org/drawingml/2006/main" wrap="square" lIns="36576" tIns="18288" rIns="36576" bIns="18288" anchor="t">
+            <a:spAutoFit/>
+          </a:bodyPr>
+          <a:lstStyle xmlns:a="http://schemas.openxmlformats.org/drawingml/2006/main"/>
+          <a:p xmlns:a="http://schemas.openxmlformats.org/drawingml/2006/main">
+            <a:pPr algn="r">
+              <a:buNone/>
+            </a:pPr>
+            <a:r>
+              <a:rPr sz="800" b="0">
+                <a:solidFill>
+                  <a:srgbClr val="5B6970"/>
+                </a:solidFill>
+                <a:latin typeface="Aptos"/>
+                <a:ea typeface="Aptos"/>
+                <a:cs typeface="Aptos"/>
+              </a:rPr>
+              <a:t>19</a:t>
+            </a:r>
+          </a:p>
+        </p:txBody>
+      </p:sp>
+      <p:sp>
+        <p:nvSpPr>
+          <p:cNvPr id="8" name="Rounded Rectangle 7">
+            <a:extLst xmlns:a="http://schemas.openxmlformats.org/drawingml/2006/main">
+              <a:ext uri="{FF2B5EF4-FFF2-40B4-BE49-F238E27FC236}">
+                <a16:creationId xmlns:a16="http://schemas.microsoft.com/office/drawing/2014/main" id="{089647A3-A401-4224-8917-B6DD9846364B}"/>
+              </a:ext>
+            </a:extLst>
+          </p:cNvPr>
+          <p:cNvSpPr>
+            <a:spLocks xmlns:a="http://schemas.openxmlformats.org/drawingml/2006/main" noGrp="1"/>
+          </p:cNvSpPr>
+          <p:nvPr/>
+        </p:nvSpPr>
+        <p:spPr>
+          <a:xfrm xmlns:a="http://schemas.openxmlformats.org/drawingml/2006/main">
+            <a:off x="411480" y="1965960"/>
+            <a:ext cx="1600200" cy="1024128"/>
+          </a:xfrm>
+          <a:prstGeom xmlns:a="http://schemas.openxmlformats.org/drawingml/2006/main" prst="roundRect">
+            <a:avLst/>
+          </a:prstGeom>
+          <a:solidFill xmlns:a="http://schemas.openxmlformats.org/drawingml/2006/main">
+            <a:srgbClr val="117A65"/>
+          </a:solidFill>
+          <a:ln xmlns:a="http://schemas.openxmlformats.org/drawingml/2006/main">
+            <a:noFill/>
+          </a:ln>
+        </p:spPr>
+        <p:style>
+          <a:lnRef xmlns:a="http://schemas.openxmlformats.org/drawingml/2006/main" idx="1">
+            <a:schemeClr val="accent1"/>
+          </a:lnRef>
+          <a:fillRef xmlns:a="http://schemas.openxmlformats.org/drawingml/2006/main" idx="3">
+            <a:schemeClr val="accent1"/>
+          </a:fillRef>
+          <a:effectRef xmlns:a="http://schemas.openxmlformats.org/drawingml/2006/main" idx="2">
+            <a:schemeClr val="accent1"/>
+          </a:effectRef>
+          <a:fontRef xmlns:a="http://schemas.openxmlformats.org/drawingml/2006/main" idx="minor">
+            <a:schemeClr val="lt1"/>
+          </a:fontRef>
+        </p:style>
+        <p:txBody>
+          <a:bodyPr xmlns:a="http://schemas.openxmlformats.org/drawingml/2006/main" anchor="ctr"/>
+          <a:lstStyle xmlns:a="http://schemas.openxmlformats.org/drawingml/2006/main"/>
+          <a:p xmlns:a="http://schemas.openxmlformats.org/drawingml/2006/main">
+            <a:pPr algn="ctr">
+              <a:buNone/>
+            </a:pPr>
+          </a:p>
+        </p:txBody>
+      </p:sp>
+      <p:sp>
+        <p:nvSpPr>
+          <p:cNvPr id="9" name="TextBox 8">
+            <a:extLst xmlns:a="http://schemas.openxmlformats.org/drawingml/2006/main">
+              <a:ext uri="{FF2B5EF4-FFF2-40B4-BE49-F238E27FC236}">
+                <a16:creationId xmlns:a16="http://schemas.microsoft.com/office/drawing/2014/main" id="{B5C96E83-9916-4349-9C5F-9D12E9DFBCFE}"/>
+              </a:ext>
+            </a:extLst>
+          </p:cNvPr>
+          <p:cNvSpPr>
+            <a:spLocks xmlns:a="http://schemas.openxmlformats.org/drawingml/2006/main" noGrp="1"/>
+          </p:cNvSpPr>
+          <p:nvPr/>
+        </p:nvSpPr>
+        <p:spPr>
+          <a:xfrm xmlns:a="http://schemas.openxmlformats.org/drawingml/2006/main">
+            <a:off x="502920" y="2103120"/>
+            <a:ext cx="1417320" cy="204216"/>
+          </a:xfrm>
+          <a:prstGeom xmlns:a="http://schemas.openxmlformats.org/drawingml/2006/main" prst="rect">
+            <a:avLst/>
+          </a:prstGeom>
+          <a:noFill xmlns:a="http://schemas.openxmlformats.org/drawingml/2006/main"/>
+        </p:spPr>
+        <p:txBody>
+          <a:bodyPr xmlns:a="http://schemas.openxmlformats.org/drawingml/2006/main" wrap="square" lIns="36576" tIns="18288" rIns="36576" bIns="18288" anchor="t">
+            <a:spAutoFit/>
+          </a:bodyPr>
+          <a:lstStyle xmlns:a="http://schemas.openxmlformats.org/drawingml/2006/main"/>
+          <a:p xmlns:a="http://schemas.openxmlformats.org/drawingml/2006/main">
+            <a:pPr algn="ctr">
+              <a:buNone/>
+            </a:pPr>
+            <a:r>
+              <a:rPr sz="1100" b="1">
+                <a:solidFill>
+                  <a:srgbClr val="FFFFFF"/>
+                </a:solidFill>
+                <a:latin typeface="Aptos"/>
+                <a:ea typeface="Aptos"/>
+                <a:cs typeface="Aptos"/>
+              </a:rPr>
+              <a:t>User asks</a:t>
+            </a:r>
+          </a:p>
+        </p:txBody>
+      </p:sp>
+      <p:sp>
+        <p:nvSpPr>
+          <p:cNvPr id="10" name="TextBox 9">
+            <a:extLst xmlns:a="http://schemas.openxmlformats.org/drawingml/2006/main">
+              <a:ext uri="{FF2B5EF4-FFF2-40B4-BE49-F238E27FC236}">
+                <a16:creationId xmlns:a16="http://schemas.microsoft.com/office/drawing/2014/main" id="{A141E9D0-F0CC-47EE-9A80-2BCA18E99B41}"/>
+              </a:ext>
+            </a:extLst>
+          </p:cNvPr>
+          <p:cNvSpPr>
+            <a:spLocks xmlns:a="http://schemas.openxmlformats.org/drawingml/2006/main" noGrp="1"/>
+          </p:cNvSpPr>
+          <p:nvPr/>
+        </p:nvSpPr>
+        <p:spPr>
+          <a:xfrm xmlns:a="http://schemas.openxmlformats.org/drawingml/2006/main">
+            <a:off x="521208" y="2404872"/>
+            <a:ext cx="1380744" cy="521208"/>
+          </a:xfrm>
+          <a:prstGeom xmlns:a="http://schemas.openxmlformats.org/drawingml/2006/main" prst="rect">
+            <a:avLst/>
+          </a:prstGeom>
+          <a:noFill xmlns:a="http://schemas.openxmlformats.org/drawingml/2006/main"/>
+        </p:spPr>
+        <p:txBody>
+          <a:bodyPr xmlns:a="http://schemas.openxmlformats.org/drawingml/2006/main" wrap="square" lIns="36576" tIns="18288" rIns="36576" bIns="18288" anchor="t">
+            <a:spAutoFit/>
+          </a:bodyPr>
+          <a:lstStyle xmlns:a="http://schemas.openxmlformats.org/drawingml/2006/main"/>
+          <a:p xmlns:a="http://schemas.openxmlformats.org/drawingml/2006/main">
+            <a:pPr algn="ctr">
+              <a:buNone/>
+            </a:pPr>
+            <a:r>
+              <a:rPr sz="860" b="0">
+                <a:solidFill>
+                  <a:srgbClr val="FFFFFF"/>
+                </a:solidFill>
+                <a:latin typeface="Aptos"/>
+                <a:ea typeface="Aptos"/>
+                <a:cs typeface="Aptos"/>
+              </a:rPr>
+              <a:t>$2500 + conservative</a:t>
+            </a:r>
+          </a:p>
+          <a:p xmlns:a="http://schemas.openxmlformats.org/drawingml/2006/main">
+            <a:pPr algn="ctr">
+              <a:buNone/>
+            </a:pPr>
+            <a:r>
+              <a:rPr sz="860" b="0">
+                <a:solidFill>
+                  <a:srgbClr val="FFFFFF"/>
+                </a:solidFill>
+                <a:latin typeface="Aptos"/>
+                <a:ea typeface="Aptos"/>
+                <a:cs typeface="Aptos"/>
+              </a:rPr>
+              <a:t>next 3 months</a:t>
+            </a:r>
+          </a:p>
+        </p:txBody>
+      </p:sp>
+      <p:sp>
+        <p:nvSpPr>
+          <p:cNvPr id="11" name="Connector 10">
+            <a:extLst xmlns:a="http://schemas.openxmlformats.org/drawingml/2006/main">
+              <a:ext uri="{FF2B5EF4-FFF2-40B4-BE49-F238E27FC236}">
+                <a16:creationId xmlns:a16="http://schemas.microsoft.com/office/drawing/2014/main" id="{F4C45320-2615-4521-991D-076CD994B5DE}"/>
+              </a:ext>
+            </a:extLst>
+          </p:cNvPr>
+          <p:cNvSpPr>
+            <a:spLocks xmlns:a="http://schemas.openxmlformats.org/drawingml/2006/main" noGrp="1"/>
+          </p:cNvSpPr>
+          <p:nvPr/>
+        </p:nvSpPr>
+        <p:spPr>
+          <a:xfrm xmlns:a="http://schemas.openxmlformats.org/drawingml/2006/main">
+            <a:off x="2011680" y="2478024"/>
+            <a:ext cx="228600" cy="0"/>
+          </a:xfrm>
+          <a:prstGeom xmlns:a="http://schemas.openxmlformats.org/drawingml/2006/main" prst="line">
+            <a:avLst/>
+          </a:prstGeom>
+          <a:ln xmlns:a="http://schemas.openxmlformats.org/drawingml/2006/main" w="20320">
+            <a:solidFill>
+              <a:srgbClr val="117A65"/>
+            </a:solidFill>
+          </a:ln>
+        </p:spPr>
+        <p:style>
+          <a:lnRef xmlns:a="http://schemas.openxmlformats.org/drawingml/2006/main" idx="2">
+            <a:schemeClr val="accent1"/>
+          </a:lnRef>
+          <a:fillRef xmlns:a="http://schemas.openxmlformats.org/drawingml/2006/main" idx="0">
+            <a:schemeClr val="accent1"/>
+          </a:fillRef>
+          <a:effectRef xmlns:a="http://schemas.openxmlformats.org/drawingml/2006/main" idx="1">
+            <a:schemeClr val="accent1"/>
+          </a:effectRef>
+          <a:fontRef xmlns:a="http://schemas.openxmlformats.org/drawingml/2006/main" idx="minor">
+            <a:schemeClr val="tx1"/>
+          </a:fontRef>
+        </p:style>
+      </p:sp>
+      <p:sp>
+        <p:nvSpPr>
+          <p:cNvPr id="12" name="Rounded Rectangle 11">
+            <a:extLst xmlns:a="http://schemas.openxmlformats.org/drawingml/2006/main">
+              <a:ext uri="{FF2B5EF4-FFF2-40B4-BE49-F238E27FC236}">
+                <a16:creationId xmlns:a16="http://schemas.microsoft.com/office/drawing/2014/main" id="{F71020EB-9D4F-4D3A-A7FC-E548CC32EC28}"/>
+              </a:ext>
+            </a:extLst>
+          </p:cNvPr>
+          <p:cNvSpPr>
+            <a:spLocks xmlns:a="http://schemas.openxmlformats.org/drawingml/2006/main" noGrp="1"/>
+          </p:cNvSpPr>
+          <p:nvPr/>
+        </p:nvSpPr>
+        <p:spPr>
+          <a:xfrm xmlns:a="http://schemas.openxmlformats.org/drawingml/2006/main">
+            <a:off x="2286000" y="1965960"/>
+            <a:ext cx="1600200" cy="1024128"/>
+          </a:xfrm>
+          <a:prstGeom xmlns:a="http://schemas.openxmlformats.org/drawingml/2006/main" prst="roundRect">
+            <a:avLst/>
+          </a:prstGeom>
+          <a:solidFill xmlns:a="http://schemas.openxmlformats.org/drawingml/2006/main">
+            <a:srgbClr val="255B92"/>
+          </a:solidFill>
+          <a:ln xmlns:a="http://schemas.openxmlformats.org/drawingml/2006/main">
+            <a:noFill/>
+          </a:ln>
+        </p:spPr>
+        <p:style>
+          <a:lnRef xmlns:a="http://schemas.openxmlformats.org/drawingml/2006/main" idx="1">
+            <a:schemeClr val="accent1"/>
+          </a:lnRef>
+          <a:fillRef xmlns:a="http://schemas.openxmlformats.org/drawingml/2006/main" idx="3">
+            <a:schemeClr val="accent1"/>
+          </a:fillRef>
+          <a:effectRef xmlns:a="http://schemas.openxmlformats.org/drawingml/2006/main" idx="2">
+            <a:schemeClr val="accent1"/>
+          </a:effectRef>
+          <a:fontRef xmlns:a="http://schemas.openxmlformats.org/drawingml/2006/main" idx="minor">
+            <a:schemeClr val="lt1"/>
+          </a:fontRef>
+        </p:style>
+        <p:txBody>
+          <a:bodyPr xmlns:a="http://schemas.openxmlformats.org/drawingml/2006/main" anchor="ctr"/>
+          <a:lstStyle xmlns:a="http://schemas.openxmlformats.org/drawingml/2006/main"/>
+          <a:p xmlns:a="http://schemas.openxmlformats.org/drawingml/2006/main">
+            <a:pPr algn="ctr">
+              <a:buNone/>
+            </a:pPr>
+          </a:p>
+        </p:txBody>
+      </p:sp>
+      <p:sp>
+        <p:nvSpPr>
+          <p:cNvPr id="13" name="TextBox 12">
+            <a:extLst xmlns:a="http://schemas.openxmlformats.org/drawingml/2006/main">
+              <a:ext uri="{FF2B5EF4-FFF2-40B4-BE49-F238E27FC236}">
+                <a16:creationId xmlns:a16="http://schemas.microsoft.com/office/drawing/2014/main" id="{F9AE5AEF-6714-41AE-9683-CC7AC9D90B22}"/>
+              </a:ext>
+            </a:extLst>
+          </p:cNvPr>
+          <p:cNvSpPr>
+            <a:spLocks xmlns:a="http://schemas.openxmlformats.org/drawingml/2006/main" noGrp="1"/>
+          </p:cNvSpPr>
+          <p:nvPr/>
+        </p:nvSpPr>
+        <p:spPr>
+          <a:xfrm xmlns:a="http://schemas.openxmlformats.org/drawingml/2006/main">
+            <a:off x="2377440" y="2103120"/>
+            <a:ext cx="1417320" cy="204216"/>
+          </a:xfrm>
+          <a:prstGeom xmlns:a="http://schemas.openxmlformats.org/drawingml/2006/main" prst="rect">
+            <a:avLst/>
+          </a:prstGeom>
+          <a:noFill xmlns:a="http://schemas.openxmlformats.org/drawingml/2006/main"/>
+        </p:spPr>
+        <p:txBody>
+          <a:bodyPr xmlns:a="http://schemas.openxmlformats.org/drawingml/2006/main" wrap="square" lIns="36576" tIns="18288" rIns="36576" bIns="18288" anchor="t">
+            <a:spAutoFit/>
+          </a:bodyPr>
+          <a:lstStyle xmlns:a="http://schemas.openxmlformats.org/drawingml/2006/main"/>
+          <a:p xmlns:a="http://schemas.openxmlformats.org/drawingml/2006/main">
+            <a:pPr algn="ctr">
+              <a:buNone/>
+            </a:pPr>
+            <a:r>
+              <a:rPr sz="1100" b="1">
+                <a:solidFill>
+                  <a:srgbClr val="FFFFFF"/>
+                </a:solidFill>
+                <a:latin typeface="Aptos"/>
+                <a:ea typeface="Aptos"/>
+                <a:cs typeface="Aptos"/>
+              </a:rPr>
+              <a:t>Classifier</a:t>
+            </a:r>
+          </a:p>
+        </p:txBody>
+      </p:sp>
+      <p:sp>
+        <p:nvSpPr>
+          <p:cNvPr id="14" name="TextBox 13">
+            <a:extLst xmlns:a="http://schemas.openxmlformats.org/drawingml/2006/main">
+              <a:ext uri="{FF2B5EF4-FFF2-40B4-BE49-F238E27FC236}">
+                <a16:creationId xmlns:a16="http://schemas.microsoft.com/office/drawing/2014/main" id="{5D5B4C73-723C-4523-A8FB-1614A7B20C2C}"/>
+              </a:ext>
+            </a:extLst>
+          </p:cNvPr>
+          <p:cNvSpPr>
+            <a:spLocks xmlns:a="http://schemas.openxmlformats.org/drawingml/2006/main" noGrp="1"/>
+          </p:cNvSpPr>
+          <p:nvPr/>
+        </p:nvSpPr>
+        <p:spPr>
+          <a:xfrm xmlns:a="http://schemas.openxmlformats.org/drawingml/2006/main">
+            <a:off x="2395728" y="2404872"/>
+            <a:ext cx="1380744" cy="521208"/>
+          </a:xfrm>
+          <a:prstGeom xmlns:a="http://schemas.openxmlformats.org/drawingml/2006/main" prst="rect">
+            <a:avLst/>
+          </a:prstGeom>
+          <a:noFill xmlns:a="http://schemas.openxmlformats.org/drawingml/2006/main"/>
+        </p:spPr>
+        <p:txBody>
+          <a:bodyPr xmlns:a="http://schemas.openxmlformats.org/drawingml/2006/main" wrap="square" lIns="36576" tIns="18288" rIns="36576" bIns="18288" anchor="t">
+            <a:spAutoFit/>
+          </a:bodyPr>
+          <a:lstStyle xmlns:a="http://schemas.openxmlformats.org/drawingml/2006/main"/>
+          <a:p xmlns:a="http://schemas.openxmlformats.org/drawingml/2006/main">
+            <a:pPr algn="ctr">
+              <a:buNone/>
+            </a:pPr>
+            <a:r>
+              <a:rPr sz="860" b="0">
+                <a:solidFill>
+                  <a:srgbClr val="FFFFFF"/>
+                </a:solidFill>
+                <a:latin typeface="Aptos"/>
+                <a:ea typeface="Aptos"/>
+                <a:cs typeface="Aptos"/>
+              </a:rPr>
+              <a:t>intent + budget</a:t>
+            </a:r>
+          </a:p>
+          <a:p xmlns:a="http://schemas.openxmlformats.org/drawingml/2006/main">
+            <a:pPr algn="ctr">
+              <a:buNone/>
+            </a:pPr>
+            <a:r>
+              <a:rPr sz="860" b="0">
+                <a:solidFill>
+                  <a:srgbClr val="FFFFFF"/>
+                </a:solidFill>
+                <a:latin typeface="Aptos"/>
+                <a:ea typeface="Aptos"/>
+                <a:cs typeface="Aptos"/>
+              </a:rPr>
+              <a:t>risk + horizon</a:t>
+            </a:r>
+          </a:p>
+        </p:txBody>
+      </p:sp>
+      <p:sp>
+        <p:nvSpPr>
+          <p:cNvPr id="15" name="Connector 14">
+            <a:extLst xmlns:a="http://schemas.openxmlformats.org/drawingml/2006/main">
+              <a:ext uri="{FF2B5EF4-FFF2-40B4-BE49-F238E27FC236}">
+                <a16:creationId xmlns:a16="http://schemas.microsoft.com/office/drawing/2014/main" id="{C7E17F59-41A6-4756-BDE1-B85F78200F74}"/>
+              </a:ext>
+            </a:extLst>
+          </p:cNvPr>
+          <p:cNvSpPr>
+            <a:spLocks xmlns:a="http://schemas.openxmlformats.org/drawingml/2006/main" noGrp="1"/>
+          </p:cNvSpPr>
+          <p:nvPr/>
+        </p:nvSpPr>
+        <p:spPr>
+          <a:xfrm xmlns:a="http://schemas.openxmlformats.org/drawingml/2006/main">
+            <a:off x="3886200" y="2478024"/>
+            <a:ext cx="228600" cy="0"/>
+          </a:xfrm>
+          <a:prstGeom xmlns:a="http://schemas.openxmlformats.org/drawingml/2006/main" prst="line">
+            <a:avLst/>
+          </a:prstGeom>
+          <a:ln xmlns:a="http://schemas.openxmlformats.org/drawingml/2006/main" w="20320">
+            <a:solidFill>
+              <a:srgbClr val="117A65"/>
+            </a:solidFill>
+          </a:ln>
+        </p:spPr>
+        <p:style>
+          <a:lnRef xmlns:a="http://schemas.openxmlformats.org/drawingml/2006/main" idx="2">
+            <a:schemeClr val="accent1"/>
+          </a:lnRef>
+          <a:fillRef xmlns:a="http://schemas.openxmlformats.org/drawingml/2006/main" idx="0">
+            <a:schemeClr val="accent1"/>
+          </a:fillRef>
+          <a:effectRef xmlns:a="http://schemas.openxmlformats.org/drawingml/2006/main" idx="1">
+            <a:schemeClr val="accent1"/>
+          </a:effectRef>
+          <a:fontRef xmlns:a="http://schemas.openxmlformats.org/drawingml/2006/main" idx="minor">
+            <a:schemeClr val="tx1"/>
+          </a:fontRef>
+        </p:style>
+      </p:sp>
+      <p:sp>
+        <p:nvSpPr>
+          <p:cNvPr id="16" name="Rounded Rectangle 15">
+            <a:extLst xmlns:a="http://schemas.openxmlformats.org/drawingml/2006/main">
+              <a:ext uri="{FF2B5EF4-FFF2-40B4-BE49-F238E27FC236}">
+                <a16:creationId xmlns:a16="http://schemas.microsoft.com/office/drawing/2014/main" id="{BA677DC8-A80A-4B6A-8A82-0D8833EFAF4F}"/>
+              </a:ext>
+            </a:extLst>
+          </p:cNvPr>
+          <p:cNvSpPr>
+            <a:spLocks xmlns:a="http://schemas.openxmlformats.org/drawingml/2006/main" noGrp="1"/>
+          </p:cNvSpPr>
+          <p:nvPr/>
+        </p:nvSpPr>
+        <p:spPr>
+          <a:xfrm xmlns:a="http://schemas.openxmlformats.org/drawingml/2006/main">
+            <a:off x="4160520" y="1965960"/>
+            <a:ext cx="1600200" cy="1024128"/>
+          </a:xfrm>
+          <a:prstGeom xmlns:a="http://schemas.openxmlformats.org/drawingml/2006/main" prst="roundRect">
+            <a:avLst/>
+          </a:prstGeom>
+          <a:solidFill xmlns:a="http://schemas.openxmlformats.org/drawingml/2006/main">
+            <a:srgbClr val="117A65"/>
+          </a:solidFill>
+          <a:ln xmlns:a="http://schemas.openxmlformats.org/drawingml/2006/main">
+            <a:noFill/>
+          </a:ln>
+        </p:spPr>
+        <p:style>
+          <a:lnRef xmlns:a="http://schemas.openxmlformats.org/drawingml/2006/main" idx="1">
+            <a:schemeClr val="accent1"/>
+          </a:lnRef>
+          <a:fillRef xmlns:a="http://schemas.openxmlformats.org/drawingml/2006/main" idx="3">
+            <a:schemeClr val="accent1"/>
+          </a:fillRef>
+          <a:effectRef xmlns:a="http://schemas.openxmlformats.org/drawingml/2006/main" idx="2">
+            <a:schemeClr val="accent1"/>
+          </a:effectRef>
+          <a:fontRef xmlns:a="http://schemas.openxmlformats.org/drawingml/2006/main" idx="minor">
+            <a:schemeClr val="lt1"/>
+          </a:fontRef>
+        </p:style>
+        <p:txBody>
+          <a:bodyPr xmlns:a="http://schemas.openxmlformats.org/drawingml/2006/main" anchor="ctr"/>
+          <a:lstStyle xmlns:a="http://schemas.openxmlformats.org/drawingml/2006/main"/>
+          <a:p xmlns:a="http://schemas.openxmlformats.org/drawingml/2006/main">
+            <a:pPr algn="ctr">
+              <a:buNone/>
+            </a:pPr>
+          </a:p>
+        </p:txBody>
+      </p:sp>
+      <p:sp>
+        <p:nvSpPr>
+          <p:cNvPr id="17" name="TextBox 16">
+            <a:extLst xmlns:a="http://schemas.openxmlformats.org/drawingml/2006/main">
+              <a:ext uri="{FF2B5EF4-FFF2-40B4-BE49-F238E27FC236}">
+                <a16:creationId xmlns:a16="http://schemas.microsoft.com/office/drawing/2014/main" id="{88972876-8F76-46B9-A187-5E19F0D99682}"/>
+              </a:ext>
+            </a:extLst>
+          </p:cNvPr>
+          <p:cNvSpPr>
+            <a:spLocks xmlns:a="http://schemas.openxmlformats.org/drawingml/2006/main" noGrp="1"/>
+          </p:cNvSpPr>
+          <p:nvPr/>
+        </p:nvSpPr>
+        <p:spPr>
+          <a:xfrm xmlns:a="http://schemas.openxmlformats.org/drawingml/2006/main">
+            <a:off x="4251959" y="2103120"/>
+            <a:ext cx="1417320" cy="204216"/>
+          </a:xfrm>
+          <a:prstGeom xmlns:a="http://schemas.openxmlformats.org/drawingml/2006/main" prst="rect">
+            <a:avLst/>
+          </a:prstGeom>
+          <a:noFill xmlns:a="http://schemas.openxmlformats.org/drawingml/2006/main"/>
+        </p:spPr>
+        <p:txBody>
+          <a:bodyPr xmlns:a="http://schemas.openxmlformats.org/drawingml/2006/main" wrap="square" lIns="36576" tIns="18288" rIns="36576" bIns="18288" anchor="t">
+            <a:spAutoFit/>
+          </a:bodyPr>
+          <a:lstStyle xmlns:a="http://schemas.openxmlformats.org/drawingml/2006/main"/>
+          <a:p xmlns:a="http://schemas.openxmlformats.org/drawingml/2006/main">
+            <a:pPr algn="ctr">
+              <a:buNone/>
+            </a:pPr>
+            <a:r>
+              <a:rPr sz="1100" b="1">
+                <a:solidFill>
+                  <a:srgbClr val="FFFFFF"/>
+                </a:solidFill>
+                <a:latin typeface="Aptos"/>
+                <a:ea typeface="Aptos"/>
+                <a:cs typeface="Aptos"/>
+              </a:rPr>
+              <a:t>Orchestrator</a:t>
+            </a:r>
+          </a:p>
+        </p:txBody>
+      </p:sp>
+      <p:sp>
+        <p:nvSpPr>
+          <p:cNvPr id="18" name="TextBox 17">
+            <a:extLst xmlns:a="http://schemas.openxmlformats.org/drawingml/2006/main">
+              <a:ext uri="{FF2B5EF4-FFF2-40B4-BE49-F238E27FC236}">
+                <a16:creationId xmlns:a16="http://schemas.microsoft.com/office/drawing/2014/main" id="{219590FD-E98F-4695-B436-86B3E2F66031}"/>
+              </a:ext>
+            </a:extLst>
+          </p:cNvPr>
+          <p:cNvSpPr>
+            <a:spLocks xmlns:a="http://schemas.openxmlformats.org/drawingml/2006/main" noGrp="1"/>
+          </p:cNvSpPr>
+          <p:nvPr/>
+        </p:nvSpPr>
+        <p:spPr>
+          <a:xfrm xmlns:a="http://schemas.openxmlformats.org/drawingml/2006/main">
+            <a:off x="4270248" y="2404872"/>
+            <a:ext cx="1380744" cy="521208"/>
+          </a:xfrm>
+          <a:prstGeom xmlns:a="http://schemas.openxmlformats.org/drawingml/2006/main" prst="rect">
+            <a:avLst/>
+          </a:prstGeom>
+          <a:noFill xmlns:a="http://schemas.openxmlformats.org/drawingml/2006/main"/>
+        </p:spPr>
+        <p:txBody>
+          <a:bodyPr xmlns:a="http://schemas.openxmlformats.org/drawingml/2006/main" wrap="square" lIns="36576" tIns="18288" rIns="36576" bIns="18288" anchor="t">
+            <a:spAutoFit/>
+          </a:bodyPr>
+          <a:lstStyle xmlns:a="http://schemas.openxmlformats.org/drawingml/2006/main"/>
+          <a:p xmlns:a="http://schemas.openxmlformats.org/drawingml/2006/main">
+            <a:pPr algn="ctr">
+              <a:buNone/>
+            </a:pPr>
+            <a:r>
+              <a:rPr sz="860" b="0">
+                <a:solidFill>
+                  <a:srgbClr val="FFFFFF"/>
+                </a:solidFill>
+                <a:latin typeface="Aptos"/>
+                <a:ea typeface="Aptos"/>
+                <a:cs typeface="Aptos"/>
+              </a:rPr>
+              <a:t>profile-aware</a:t>
+            </a:r>
+          </a:p>
+          <a:p xmlns:a="http://schemas.openxmlformats.org/drawingml/2006/main">
+            <a:pPr algn="ctr">
+              <a:buNone/>
+            </a:pPr>
+            <a:r>
+              <a:rPr sz="860" b="0">
+                <a:solidFill>
+                  <a:srgbClr val="FFFFFF"/>
+                </a:solidFill>
+                <a:latin typeface="Aptos"/>
+                <a:ea typeface="Aptos"/>
+                <a:cs typeface="Aptos"/>
+              </a:rPr>
+              <a:t>ticker selection</a:t>
+            </a:r>
+          </a:p>
+        </p:txBody>
+      </p:sp>
+      <p:sp>
+        <p:nvSpPr>
+          <p:cNvPr id="19" name="Connector 18">
+            <a:extLst xmlns:a="http://schemas.openxmlformats.org/drawingml/2006/main">
+              <a:ext uri="{FF2B5EF4-FFF2-40B4-BE49-F238E27FC236}">
+                <a16:creationId xmlns:a16="http://schemas.microsoft.com/office/drawing/2014/main" id="{946F74FF-816E-4C68-BE83-C10C18F8ACF4}"/>
+              </a:ext>
+            </a:extLst>
+          </p:cNvPr>
+          <p:cNvSpPr>
+            <a:spLocks xmlns:a="http://schemas.openxmlformats.org/drawingml/2006/main" noGrp="1"/>
+          </p:cNvSpPr>
+          <p:nvPr/>
+        </p:nvSpPr>
+        <p:spPr>
+          <a:xfrm xmlns:a="http://schemas.openxmlformats.org/drawingml/2006/main">
+            <a:off x="5760720" y="2478024"/>
+            <a:ext cx="228600" cy="0"/>
+          </a:xfrm>
+          <a:prstGeom xmlns:a="http://schemas.openxmlformats.org/drawingml/2006/main" prst="line">
+            <a:avLst/>
+          </a:prstGeom>
+          <a:ln xmlns:a="http://schemas.openxmlformats.org/drawingml/2006/main" w="20320">
+            <a:solidFill>
+              <a:srgbClr val="117A65"/>
+            </a:solidFill>
+          </a:ln>
+        </p:spPr>
+        <p:style>
+          <a:lnRef xmlns:a="http://schemas.openxmlformats.org/drawingml/2006/main" idx="2">
+            <a:schemeClr val="accent1"/>
+          </a:lnRef>
+          <a:fillRef xmlns:a="http://schemas.openxmlformats.org/drawingml/2006/main" idx="0">
+            <a:schemeClr val="accent1"/>
+          </a:fillRef>
+          <a:effectRef xmlns:a="http://schemas.openxmlformats.org/drawingml/2006/main" idx="1">
+            <a:schemeClr val="accent1"/>
+          </a:effectRef>
+          <a:fontRef xmlns:a="http://schemas.openxmlformats.org/drawingml/2006/main" idx="minor">
+            <a:schemeClr val="tx1"/>
+          </a:fontRef>
+        </p:style>
+      </p:sp>
+      <p:sp>
+        <p:nvSpPr>
+          <p:cNvPr id="20" name="Rounded Rectangle 19">
+            <a:extLst xmlns:a="http://schemas.openxmlformats.org/drawingml/2006/main">
+              <a:ext uri="{FF2B5EF4-FFF2-40B4-BE49-F238E27FC236}">
+                <a16:creationId xmlns:a16="http://schemas.microsoft.com/office/drawing/2014/main" id="{03258365-A023-469D-B0AF-96D141B7D22C}"/>
+              </a:ext>
+            </a:extLst>
+          </p:cNvPr>
+          <p:cNvSpPr>
+            <a:spLocks xmlns:a="http://schemas.openxmlformats.org/drawingml/2006/main" noGrp="1"/>
+          </p:cNvSpPr>
+          <p:nvPr/>
+        </p:nvSpPr>
+        <p:spPr>
+          <a:xfrm xmlns:a="http://schemas.openxmlformats.org/drawingml/2006/main">
+            <a:off x="6035040" y="1965960"/>
+            <a:ext cx="1600200" cy="1024128"/>
+          </a:xfrm>
+          <a:prstGeom xmlns:a="http://schemas.openxmlformats.org/drawingml/2006/main" prst="roundRect">
+            <a:avLst/>
+          </a:prstGeom>
+          <a:solidFill xmlns:a="http://schemas.openxmlformats.org/drawingml/2006/main">
+            <a:srgbClr val="255B92"/>
+          </a:solidFill>
+          <a:ln xmlns:a="http://schemas.openxmlformats.org/drawingml/2006/main">
+            <a:noFill/>
+          </a:ln>
+        </p:spPr>
+        <p:style>
+          <a:lnRef xmlns:a="http://schemas.openxmlformats.org/drawingml/2006/main" idx="1">
+            <a:schemeClr val="accent1"/>
+          </a:lnRef>
+          <a:fillRef xmlns:a="http://schemas.openxmlformats.org/drawingml/2006/main" idx="3">
+            <a:schemeClr val="accent1"/>
+          </a:fillRef>
+          <a:effectRef xmlns:a="http://schemas.openxmlformats.org/drawingml/2006/main" idx="2">
+            <a:schemeClr val="accent1"/>
+          </a:effectRef>
+          <a:fontRef xmlns:a="http://schemas.openxmlformats.org/drawingml/2006/main" idx="minor">
+            <a:schemeClr val="lt1"/>
+          </a:fontRef>
+        </p:style>
+        <p:txBody>
+          <a:bodyPr xmlns:a="http://schemas.openxmlformats.org/drawingml/2006/main" anchor="ctr"/>
+          <a:lstStyle xmlns:a="http://schemas.openxmlformats.org/drawingml/2006/main"/>
+          <a:p xmlns:a="http://schemas.openxmlformats.org/drawingml/2006/main">
+            <a:pPr algn="ctr">
+              <a:buNone/>
+            </a:pPr>
+          </a:p>
+        </p:txBody>
+      </p:sp>
+      <p:sp>
+        <p:nvSpPr>
+          <p:cNvPr id="21" name="TextBox 20">
+            <a:extLst xmlns:a="http://schemas.openxmlformats.org/drawingml/2006/main">
+              <a:ext uri="{FF2B5EF4-FFF2-40B4-BE49-F238E27FC236}">
+                <a16:creationId xmlns:a16="http://schemas.microsoft.com/office/drawing/2014/main" id="{2D212894-AEE3-4AF2-923D-8601B096F865}"/>
+              </a:ext>
+            </a:extLst>
+          </p:cNvPr>
+          <p:cNvSpPr>
+            <a:spLocks xmlns:a="http://schemas.openxmlformats.org/drawingml/2006/main" noGrp="1"/>
+          </p:cNvSpPr>
+          <p:nvPr/>
+        </p:nvSpPr>
+        <p:spPr>
+          <a:xfrm xmlns:a="http://schemas.openxmlformats.org/drawingml/2006/main">
+            <a:off x="6126479" y="2103120"/>
+            <a:ext cx="1417320" cy="204216"/>
+          </a:xfrm>
+          <a:prstGeom xmlns:a="http://schemas.openxmlformats.org/drawingml/2006/main" prst="rect">
+            <a:avLst/>
+          </a:prstGeom>
+          <a:noFill xmlns:a="http://schemas.openxmlformats.org/drawingml/2006/main"/>
+        </p:spPr>
+        <p:txBody>
+          <a:bodyPr xmlns:a="http://schemas.openxmlformats.org/drawingml/2006/main" wrap="square" lIns="36576" tIns="18288" rIns="36576" bIns="18288" anchor="t">
+            <a:spAutoFit/>
+          </a:bodyPr>
+          <a:lstStyle xmlns:a="http://schemas.openxmlformats.org/drawingml/2006/main"/>
+          <a:p xmlns:a="http://schemas.openxmlformats.org/drawingml/2006/main">
+            <a:pPr algn="ctr">
+              <a:buNone/>
+            </a:pPr>
+            <a:r>
+              <a:rPr sz="1100" b="1">
+                <a:solidFill>
+                  <a:srgbClr val="FFFFFF"/>
+                </a:solidFill>
+                <a:latin typeface="Aptos"/>
+                <a:ea typeface="Aptos"/>
+                <a:cs typeface="Aptos"/>
+              </a:rPr>
+              <a:t>Forecast</a:t>
+            </a:r>
+          </a:p>
+        </p:txBody>
+      </p:sp>
+      <p:sp>
+        <p:nvSpPr>
+          <p:cNvPr id="22" name="TextBox 21">
+            <a:extLst xmlns:a="http://schemas.openxmlformats.org/drawingml/2006/main">
+              <a:ext uri="{FF2B5EF4-FFF2-40B4-BE49-F238E27FC236}">
+                <a16:creationId xmlns:a16="http://schemas.microsoft.com/office/drawing/2014/main" id="{450A180B-B48C-462A-8F3A-D04B5A606D45}"/>
+              </a:ext>
+            </a:extLst>
+          </p:cNvPr>
+          <p:cNvSpPr>
+            <a:spLocks xmlns:a="http://schemas.openxmlformats.org/drawingml/2006/main" noGrp="1"/>
+          </p:cNvSpPr>
+          <p:nvPr/>
+        </p:nvSpPr>
+        <p:spPr>
+          <a:xfrm xmlns:a="http://schemas.openxmlformats.org/drawingml/2006/main">
+            <a:off x="6144768" y="2404872"/>
+            <a:ext cx="1380744" cy="521208"/>
+          </a:xfrm>
+          <a:prstGeom xmlns:a="http://schemas.openxmlformats.org/drawingml/2006/main" prst="rect">
+            <a:avLst/>
+          </a:prstGeom>
+          <a:noFill xmlns:a="http://schemas.openxmlformats.org/drawingml/2006/main"/>
+        </p:spPr>
+        <p:txBody>
+          <a:bodyPr xmlns:a="http://schemas.openxmlformats.org/drawingml/2006/main" wrap="square" lIns="36576" tIns="18288" rIns="36576" bIns="18288" anchor="t">
+            <a:spAutoFit/>
+          </a:bodyPr>
+          <a:lstStyle xmlns:a="http://schemas.openxmlformats.org/drawingml/2006/main"/>
+          <a:p xmlns:a="http://schemas.openxmlformats.org/drawingml/2006/main">
+            <a:pPr algn="ctr">
+              <a:buNone/>
+            </a:pPr>
+            <a:r>
+              <a:rPr sz="860" b="0">
+                <a:solidFill>
+                  <a:srgbClr val="FFFFFF"/>
+                </a:solidFill>
+                <a:latin typeface="Aptos"/>
+                <a:ea typeface="Aptos"/>
+                <a:cs typeface="Aptos"/>
+              </a:rPr>
+              <a:t>uses detected</a:t>
+            </a:r>
+          </a:p>
+          <a:p xmlns:a="http://schemas.openxmlformats.org/drawingml/2006/main">
+            <a:pPr algn="ctr">
+              <a:buNone/>
+            </a:pPr>
+            <a:r>
+              <a:rPr sz="860" b="0">
+                <a:solidFill>
+                  <a:srgbClr val="FFFFFF"/>
+                </a:solidFill>
+                <a:latin typeface="Aptos"/>
+                <a:ea typeface="Aptos"/>
+                <a:cs typeface="Aptos"/>
+              </a:rPr>
+              <a:t>90-day horizon</a:t>
+            </a:r>
+          </a:p>
+        </p:txBody>
+      </p:sp>
+      <p:sp>
+        <p:nvSpPr>
+          <p:cNvPr id="23" name="Connector 22">
+            <a:extLst xmlns:a="http://schemas.openxmlformats.org/drawingml/2006/main">
+              <a:ext uri="{FF2B5EF4-FFF2-40B4-BE49-F238E27FC236}">
+                <a16:creationId xmlns:a16="http://schemas.microsoft.com/office/drawing/2014/main" id="{5F85DFC5-1E20-425A-BC6F-E462167DBC16}"/>
+              </a:ext>
+            </a:extLst>
+          </p:cNvPr>
+          <p:cNvSpPr>
+            <a:spLocks xmlns:a="http://schemas.openxmlformats.org/drawingml/2006/main" noGrp="1"/>
+          </p:cNvSpPr>
+          <p:nvPr/>
+        </p:nvSpPr>
+        <p:spPr>
+          <a:xfrm xmlns:a="http://schemas.openxmlformats.org/drawingml/2006/main">
+            <a:off x="7635240" y="2478024"/>
+            <a:ext cx="228600" cy="0"/>
+          </a:xfrm>
+          <a:prstGeom xmlns:a="http://schemas.openxmlformats.org/drawingml/2006/main" prst="line">
+            <a:avLst/>
+          </a:prstGeom>
+          <a:ln xmlns:a="http://schemas.openxmlformats.org/drawingml/2006/main" w="20320">
+            <a:solidFill>
+              <a:srgbClr val="117A65"/>
+            </a:solidFill>
+          </a:ln>
+        </p:spPr>
+        <p:style>
+          <a:lnRef xmlns:a="http://schemas.openxmlformats.org/drawingml/2006/main" idx="2">
+            <a:schemeClr val="accent1"/>
+          </a:lnRef>
+          <a:fillRef xmlns:a="http://schemas.openxmlformats.org/drawingml/2006/main" idx="0">
+            <a:schemeClr val="accent1"/>
+          </a:fillRef>
+          <a:effectRef xmlns:a="http://schemas.openxmlformats.org/drawingml/2006/main" idx="1">
+            <a:schemeClr val="accent1"/>
+          </a:effectRef>
+          <a:fontRef xmlns:a="http://schemas.openxmlformats.org/drawingml/2006/main" idx="minor">
+            <a:schemeClr val="tx1"/>
+          </a:fontRef>
+        </p:style>
+      </p:sp>
+      <p:sp>
+        <p:nvSpPr>
+          <p:cNvPr id="24" name="Rounded Rectangle 23">
+            <a:extLst xmlns:a="http://schemas.openxmlformats.org/drawingml/2006/main">
+              <a:ext uri="{FF2B5EF4-FFF2-40B4-BE49-F238E27FC236}">
+                <a16:creationId xmlns:a16="http://schemas.microsoft.com/office/drawing/2014/main" id="{8F255F51-9940-4570-96BF-3F17E2D87F55}"/>
+              </a:ext>
+            </a:extLst>
+          </p:cNvPr>
+          <p:cNvSpPr>
+            <a:spLocks xmlns:a="http://schemas.openxmlformats.org/drawingml/2006/main" noGrp="1"/>
+          </p:cNvSpPr>
+          <p:nvPr/>
+        </p:nvSpPr>
+        <p:spPr>
+          <a:xfrm xmlns:a="http://schemas.openxmlformats.org/drawingml/2006/main">
+            <a:off x="7909559" y="1965960"/>
+            <a:ext cx="1600200" cy="1024128"/>
+          </a:xfrm>
+          <a:prstGeom xmlns:a="http://schemas.openxmlformats.org/drawingml/2006/main" prst="roundRect">
+            <a:avLst/>
+          </a:prstGeom>
+          <a:solidFill xmlns:a="http://schemas.openxmlformats.org/drawingml/2006/main">
+            <a:srgbClr val="117A65"/>
+          </a:solidFill>
+          <a:ln xmlns:a="http://schemas.openxmlformats.org/drawingml/2006/main">
+            <a:noFill/>
+          </a:ln>
+        </p:spPr>
+        <p:style>
+          <a:lnRef xmlns:a="http://schemas.openxmlformats.org/drawingml/2006/main" idx="1">
+            <a:schemeClr val="accent1"/>
+          </a:lnRef>
+          <a:fillRef xmlns:a="http://schemas.openxmlformats.org/drawingml/2006/main" idx="3">
+            <a:schemeClr val="accent1"/>
+          </a:fillRef>
+          <a:effectRef xmlns:a="http://schemas.openxmlformats.org/drawingml/2006/main" idx="2">
+            <a:schemeClr val="accent1"/>
+          </a:effectRef>
+          <a:fontRef xmlns:a="http://schemas.openxmlformats.org/drawingml/2006/main" idx="minor">
+            <a:schemeClr val="lt1"/>
+          </a:fontRef>
+        </p:style>
+        <p:txBody>
+          <a:bodyPr xmlns:a="http://schemas.openxmlformats.org/drawingml/2006/main" anchor="ctr"/>
+          <a:lstStyle xmlns:a="http://schemas.openxmlformats.org/drawingml/2006/main"/>
+          <a:p xmlns:a="http://schemas.openxmlformats.org/drawingml/2006/main">
+            <a:pPr algn="ctr">
+              <a:buNone/>
+            </a:pPr>
+          </a:p>
+        </p:txBody>
+      </p:sp>
+      <p:sp>
+        <p:nvSpPr>
+          <p:cNvPr id="25" name="TextBox 24">
+            <a:extLst xmlns:a="http://schemas.openxmlformats.org/drawingml/2006/main">
+              <a:ext uri="{FF2B5EF4-FFF2-40B4-BE49-F238E27FC236}">
+                <a16:creationId xmlns:a16="http://schemas.microsoft.com/office/drawing/2014/main" id="{6DC20D06-9C61-4D39-A37E-4CAB9AE2F970}"/>
+              </a:ext>
+            </a:extLst>
+          </p:cNvPr>
+          <p:cNvSpPr>
+            <a:spLocks xmlns:a="http://schemas.openxmlformats.org/drawingml/2006/main" noGrp="1"/>
+          </p:cNvSpPr>
+          <p:nvPr/>
+        </p:nvSpPr>
+        <p:spPr>
+          <a:xfrm xmlns:a="http://schemas.openxmlformats.org/drawingml/2006/main">
+            <a:off x="8000999" y="2103120"/>
+            <a:ext cx="1417320" cy="204216"/>
+          </a:xfrm>
+          <a:prstGeom xmlns:a="http://schemas.openxmlformats.org/drawingml/2006/main" prst="rect">
+            <a:avLst/>
+          </a:prstGeom>
+          <a:noFill xmlns:a="http://schemas.openxmlformats.org/drawingml/2006/main"/>
+        </p:spPr>
+        <p:txBody>
+          <a:bodyPr xmlns:a="http://schemas.openxmlformats.org/drawingml/2006/main" wrap="square" lIns="36576" tIns="18288" rIns="36576" bIns="18288" anchor="t">
+            <a:spAutoFit/>
+          </a:bodyPr>
+          <a:lstStyle xmlns:a="http://schemas.openxmlformats.org/drawingml/2006/main"/>
+          <a:p xmlns:a="http://schemas.openxmlformats.org/drawingml/2006/main">
+            <a:pPr algn="ctr">
+              <a:buNone/>
+            </a:pPr>
+            <a:r>
+              <a:rPr sz="1100" b="1">
+                <a:solidFill>
+                  <a:srgbClr val="FFFFFF"/>
+                </a:solidFill>
+                <a:latin typeface="Aptos"/>
+                <a:ea typeface="Aptos"/>
+                <a:cs typeface="Aptos"/>
+              </a:rPr>
+              <a:t>Answer UI</a:t>
+            </a:r>
+          </a:p>
+        </p:txBody>
+      </p:sp>
+      <p:sp>
+        <p:nvSpPr>
+          <p:cNvPr id="26" name="TextBox 25">
+            <a:extLst xmlns:a="http://schemas.openxmlformats.org/drawingml/2006/main">
+              <a:ext uri="{FF2B5EF4-FFF2-40B4-BE49-F238E27FC236}">
+                <a16:creationId xmlns:a16="http://schemas.microsoft.com/office/drawing/2014/main" id="{9DF2AE2A-858B-48C2-9787-0A065C63E879}"/>
+              </a:ext>
+            </a:extLst>
+          </p:cNvPr>
+          <p:cNvSpPr>
+            <a:spLocks xmlns:a="http://schemas.openxmlformats.org/drawingml/2006/main" noGrp="1"/>
+          </p:cNvSpPr>
+          <p:nvPr/>
+        </p:nvSpPr>
+        <p:spPr>
+          <a:xfrm xmlns:a="http://schemas.openxmlformats.org/drawingml/2006/main">
+            <a:off x="8019287" y="2404872"/>
+            <a:ext cx="1380744" cy="521208"/>
+          </a:xfrm>
+          <a:prstGeom xmlns:a="http://schemas.openxmlformats.org/drawingml/2006/main" prst="rect">
+            <a:avLst/>
+          </a:prstGeom>
+          <a:noFill xmlns:a="http://schemas.openxmlformats.org/drawingml/2006/main"/>
+        </p:spPr>
+        <p:txBody>
+          <a:bodyPr xmlns:a="http://schemas.openxmlformats.org/drawingml/2006/main" wrap="square" lIns="36576" tIns="18288" rIns="36576" bIns="18288" anchor="t">
+            <a:spAutoFit/>
+          </a:bodyPr>
+          <a:lstStyle xmlns:a="http://schemas.openxmlformats.org/drawingml/2006/main"/>
+          <a:p xmlns:a="http://schemas.openxmlformats.org/drawingml/2006/main">
+            <a:pPr algn="ctr">
+              <a:buNone/>
+            </a:pPr>
+            <a:r>
+              <a:rPr sz="860" b="0">
+                <a:solidFill>
+                  <a:srgbClr val="FFFFFF"/>
+                </a:solidFill>
+                <a:latin typeface="Aptos"/>
+                <a:ea typeface="Aptos"/>
+                <a:cs typeface="Aptos"/>
+              </a:rPr>
+              <a:t>shows routing</a:t>
+            </a:r>
+          </a:p>
+          <a:p xmlns:a="http://schemas.openxmlformats.org/drawingml/2006/main">
+            <a:pPr algn="ctr">
+              <a:buNone/>
+            </a:pPr>
+            <a:r>
+              <a:rPr sz="860" b="0">
+                <a:solidFill>
+                  <a:srgbClr val="FFFFFF"/>
+                </a:solidFill>
+                <a:latin typeface="Aptos"/>
+                <a:ea typeface="Aptos"/>
+                <a:cs typeface="Aptos"/>
+              </a:rPr>
+              <a:t>confidence</a:t>
+            </a:r>
+          </a:p>
+        </p:txBody>
+      </p:sp>
+      <p:sp>
+        <p:nvSpPr>
+          <p:cNvPr id="27" name="Connector 26">
+            <a:extLst xmlns:a="http://schemas.openxmlformats.org/drawingml/2006/main">
+              <a:ext uri="{FF2B5EF4-FFF2-40B4-BE49-F238E27FC236}">
+                <a16:creationId xmlns:a16="http://schemas.microsoft.com/office/drawing/2014/main" id="{D909458E-4F97-4F57-94C6-B34B6A439F31}"/>
+              </a:ext>
+            </a:extLst>
+          </p:cNvPr>
+          <p:cNvSpPr>
+            <a:spLocks xmlns:a="http://schemas.openxmlformats.org/drawingml/2006/main" noGrp="1"/>
+          </p:cNvSpPr>
+          <p:nvPr/>
+        </p:nvSpPr>
+        <p:spPr>
+          <a:xfrm xmlns:a="http://schemas.openxmlformats.org/drawingml/2006/main">
+            <a:off x="9509759" y="2478024"/>
+            <a:ext cx="228600" cy="0"/>
+          </a:xfrm>
+          <a:prstGeom xmlns:a="http://schemas.openxmlformats.org/drawingml/2006/main" prst="line">
+            <a:avLst/>
+          </a:prstGeom>
+          <a:ln xmlns:a="http://schemas.openxmlformats.org/drawingml/2006/main" w="20320">
+            <a:solidFill>
+              <a:srgbClr val="117A65"/>
+            </a:solidFill>
+          </a:ln>
+        </p:spPr>
+        <p:style>
+          <a:lnRef xmlns:a="http://schemas.openxmlformats.org/drawingml/2006/main" idx="2">
+            <a:schemeClr val="accent1"/>
+          </a:lnRef>
+          <a:fillRef xmlns:a="http://schemas.openxmlformats.org/drawingml/2006/main" idx="0">
+            <a:schemeClr val="accent1"/>
+          </a:fillRef>
+          <a:effectRef xmlns:a="http://schemas.openxmlformats.org/drawingml/2006/main" idx="1">
+            <a:schemeClr val="accent1"/>
+          </a:effectRef>
+          <a:fontRef xmlns:a="http://schemas.openxmlformats.org/drawingml/2006/main" idx="minor">
+            <a:schemeClr val="tx1"/>
+          </a:fontRef>
+        </p:style>
+      </p:sp>
+      <p:sp>
+        <p:nvSpPr>
+          <p:cNvPr id="28" name="Rounded Rectangle 27">
+            <a:extLst xmlns:a="http://schemas.openxmlformats.org/drawingml/2006/main">
+              <a:ext uri="{FF2B5EF4-FFF2-40B4-BE49-F238E27FC236}">
+                <a16:creationId xmlns:a16="http://schemas.microsoft.com/office/drawing/2014/main" id="{6001313F-7EB7-4078-9E9E-138E2B6739C2}"/>
+              </a:ext>
+            </a:extLst>
+          </p:cNvPr>
+          <p:cNvSpPr>
+            <a:spLocks xmlns:a="http://schemas.openxmlformats.org/drawingml/2006/main" noGrp="1"/>
+          </p:cNvSpPr>
+          <p:nvPr/>
+        </p:nvSpPr>
+        <p:spPr>
+          <a:xfrm xmlns:a="http://schemas.openxmlformats.org/drawingml/2006/main">
+            <a:off x="9784080" y="1965960"/>
+            <a:ext cx="1600200" cy="1024128"/>
+          </a:xfrm>
+          <a:prstGeom xmlns:a="http://schemas.openxmlformats.org/drawingml/2006/main" prst="roundRect">
+            <a:avLst/>
+          </a:prstGeom>
+          <a:solidFill xmlns:a="http://schemas.openxmlformats.org/drawingml/2006/main">
+            <a:srgbClr val="255B92"/>
+          </a:solidFill>
+          <a:ln xmlns:a="http://schemas.openxmlformats.org/drawingml/2006/main">
+            <a:noFill/>
+          </a:ln>
+        </p:spPr>
+        <p:style>
+          <a:lnRef xmlns:a="http://schemas.openxmlformats.org/drawingml/2006/main" idx="1">
+            <a:schemeClr val="accent1"/>
+          </a:lnRef>
+          <a:fillRef xmlns:a="http://schemas.openxmlformats.org/drawingml/2006/main" idx="3">
+            <a:schemeClr val="accent1"/>
+          </a:fillRef>
+          <a:effectRef xmlns:a="http://schemas.openxmlformats.org/drawingml/2006/main" idx="2">
+            <a:schemeClr val="accent1"/>
+          </a:effectRef>
+          <a:fontRef xmlns:a="http://schemas.openxmlformats.org/drawingml/2006/main" idx="minor">
+            <a:schemeClr val="lt1"/>
+          </a:fontRef>
+        </p:style>
+        <p:txBody>
+          <a:bodyPr xmlns:a="http://schemas.openxmlformats.org/drawingml/2006/main" anchor="ctr"/>
+          <a:lstStyle xmlns:a="http://schemas.openxmlformats.org/drawingml/2006/main"/>
+          <a:p xmlns:a="http://schemas.openxmlformats.org/drawingml/2006/main">
+            <a:pPr algn="ctr">
+              <a:buNone/>
+            </a:pPr>
+          </a:p>
+        </p:txBody>
+      </p:sp>
+      <p:sp>
+        <p:nvSpPr>
+          <p:cNvPr id="29" name="TextBox 28">
+            <a:extLst xmlns:a="http://schemas.openxmlformats.org/drawingml/2006/main">
+              <a:ext uri="{FF2B5EF4-FFF2-40B4-BE49-F238E27FC236}">
+                <a16:creationId xmlns:a16="http://schemas.microsoft.com/office/drawing/2014/main" id="{D925285D-52C8-43D9-AF10-6D1DBB04125B}"/>
+              </a:ext>
+            </a:extLst>
+          </p:cNvPr>
+          <p:cNvSpPr>
+            <a:spLocks xmlns:a="http://schemas.openxmlformats.org/drawingml/2006/main" noGrp="1"/>
+          </p:cNvSpPr>
+          <p:nvPr/>
+        </p:nvSpPr>
+        <p:spPr>
+          <a:xfrm xmlns:a="http://schemas.openxmlformats.org/drawingml/2006/main">
+            <a:off x="9875519" y="2103120"/>
+            <a:ext cx="1417320" cy="204216"/>
+          </a:xfrm>
+          <a:prstGeom xmlns:a="http://schemas.openxmlformats.org/drawingml/2006/main" prst="rect">
+            <a:avLst/>
+          </a:prstGeom>
+          <a:noFill xmlns:a="http://schemas.openxmlformats.org/drawingml/2006/main"/>
+        </p:spPr>
+        <p:txBody>
+          <a:bodyPr xmlns:a="http://schemas.openxmlformats.org/drawingml/2006/main" wrap="square" lIns="36576" tIns="18288" rIns="36576" bIns="18288" anchor="t">
+            <a:spAutoFit/>
+          </a:bodyPr>
+          <a:lstStyle xmlns:a="http://schemas.openxmlformats.org/drawingml/2006/main"/>
+          <a:p xmlns:a="http://schemas.openxmlformats.org/drawingml/2006/main">
+            <a:pPr algn="ctr">
+              <a:buNone/>
+            </a:pPr>
+            <a:r>
+              <a:rPr sz="1100" b="1">
+                <a:solidFill>
+                  <a:srgbClr val="FFFFFF"/>
+                </a:solidFill>
+                <a:latin typeface="Aptos"/>
+                <a:ea typeface="Aptos"/>
+                <a:cs typeface="Aptos"/>
+              </a:rPr>
+              <a:t>Tests</a:t>
+            </a:r>
+          </a:p>
+        </p:txBody>
+      </p:sp>
+      <p:sp>
+        <p:nvSpPr>
+          <p:cNvPr id="30" name="TextBox 29">
+            <a:extLst xmlns:a="http://schemas.openxmlformats.org/drawingml/2006/main">
+              <a:ext uri="{FF2B5EF4-FFF2-40B4-BE49-F238E27FC236}">
+                <a16:creationId xmlns:a16="http://schemas.microsoft.com/office/drawing/2014/main" id="{23D0FDE9-6128-43C5-8A6E-4AB50B948918}"/>
+              </a:ext>
+            </a:extLst>
+          </p:cNvPr>
+          <p:cNvSpPr>
+            <a:spLocks xmlns:a="http://schemas.openxmlformats.org/drawingml/2006/main" noGrp="1"/>
+          </p:cNvSpPr>
+          <p:nvPr/>
+        </p:nvSpPr>
+        <p:spPr>
+          <a:xfrm xmlns:a="http://schemas.openxmlformats.org/drawingml/2006/main">
+            <a:off x="9893807" y="2404872"/>
+            <a:ext cx="1380744" cy="521208"/>
+          </a:xfrm>
+          <a:prstGeom xmlns:a="http://schemas.openxmlformats.org/drawingml/2006/main" prst="rect">
+            <a:avLst/>
+          </a:prstGeom>
+          <a:noFill xmlns:a="http://schemas.openxmlformats.org/drawingml/2006/main"/>
+        </p:spPr>
+        <p:txBody>
+          <a:bodyPr xmlns:a="http://schemas.openxmlformats.org/drawingml/2006/main" wrap="square" lIns="36576" tIns="18288" rIns="36576" bIns="18288" anchor="t">
+            <a:spAutoFit/>
+          </a:bodyPr>
+          <a:lstStyle xmlns:a="http://schemas.openxmlformats.org/drawingml/2006/main"/>
+          <a:p xmlns:a="http://schemas.openxmlformats.org/drawingml/2006/main">
+            <a:pPr algn="ctr">
+              <a:buNone/>
+            </a:pPr>
+            <a:r>
+              <a:rPr sz="860" b="0">
+                <a:solidFill>
+                  <a:srgbClr val="FFFFFF"/>
+                </a:solidFill>
+                <a:latin typeface="Aptos"/>
+                <a:ea typeface="Aptos"/>
+                <a:cs typeface="Aptos"/>
+              </a:rPr>
+              <a:t>20 passing</a:t>
+            </a:r>
+          </a:p>
+          <a:p xmlns:a="http://schemas.openxmlformats.org/drawingml/2006/main">
+            <a:pPr algn="ctr">
+              <a:buNone/>
+            </a:pPr>
+            <a:r>
+              <a:rPr sz="860" b="0">
+                <a:solidFill>
+                  <a:srgbClr val="FFFFFF"/>
+                </a:solidFill>
+                <a:latin typeface="Aptos"/>
+                <a:ea typeface="Aptos"/>
+                <a:cs typeface="Aptos"/>
+              </a:rPr>
+              <a:t>regressions</a:t>
+            </a:r>
+          </a:p>
+        </p:txBody>
+      </p:sp>
+      <p:sp>
+        <p:nvSpPr>
+          <p:cNvPr id="31" name="Rounded Rectangle 30">
+            <a:extLst xmlns:a="http://schemas.openxmlformats.org/drawingml/2006/main">
+              <a:ext uri="{FF2B5EF4-FFF2-40B4-BE49-F238E27FC236}">
+                <a16:creationId xmlns:a16="http://schemas.microsoft.com/office/drawing/2014/main" id="{7155E6FB-B27F-4F22-AAEA-FE780A081E22}"/>
+              </a:ext>
+            </a:extLst>
+          </p:cNvPr>
+          <p:cNvSpPr>
+            <a:spLocks xmlns:a="http://schemas.openxmlformats.org/drawingml/2006/main" noGrp="1"/>
+          </p:cNvSpPr>
+          <p:nvPr/>
+        </p:nvSpPr>
+        <p:spPr>
+          <a:xfrm xmlns:a="http://schemas.openxmlformats.org/drawingml/2006/main">
+            <a:off x="685800" y="3703320"/>
+            <a:ext cx="3383280" cy="1325880"/>
+          </a:xfrm>
+          <a:prstGeom xmlns:a="http://schemas.openxmlformats.org/drawingml/2006/main" prst="roundRect">
+            <a:avLst/>
+          </a:prstGeom>
+          <a:solidFill xmlns:a="http://schemas.openxmlformats.org/drawingml/2006/main">
+            <a:srgbClr val="FFFFFF"/>
+          </a:solidFill>
+          <a:ln xmlns:a="http://schemas.openxmlformats.org/drawingml/2006/main" w="12700">
+            <a:solidFill>
+              <a:srgbClr val="CFDADA"/>
+            </a:solidFill>
+          </a:ln>
+        </p:spPr>
+        <p:style>
+          <a:lnRef xmlns:a="http://schemas.openxmlformats.org/drawingml/2006/main" idx="1">
+            <a:schemeClr val="accent1"/>
+          </a:lnRef>
+          <a:fillRef xmlns:a="http://schemas.openxmlformats.org/drawingml/2006/main" idx="3">
+            <a:schemeClr val="accent1"/>
+          </a:fillRef>
+          <a:effectRef xmlns:a="http://schemas.openxmlformats.org/drawingml/2006/main" idx="2">
+            <a:schemeClr val="accent1"/>
+          </a:effectRef>
+          <a:fontRef xmlns:a="http://schemas.openxmlformats.org/drawingml/2006/main" idx="minor">
+            <a:schemeClr val="lt1"/>
+          </a:fontRef>
+        </p:style>
+        <p:txBody>
+          <a:bodyPr xmlns:a="http://schemas.openxmlformats.org/drawingml/2006/main" anchor="ctr"/>
+          <a:lstStyle xmlns:a="http://schemas.openxmlformats.org/drawingml/2006/main"/>
+          <a:p xmlns:a="http://schemas.openxmlformats.org/drawingml/2006/main">
+            <a:pPr algn="ctr">
+              <a:buNone/>
+            </a:pPr>
+          </a:p>
+        </p:txBody>
+      </p:sp>
+      <p:sp>
+        <p:nvSpPr>
+          <p:cNvPr id="32" name="TextBox 31">
+            <a:extLst xmlns:a="http://schemas.openxmlformats.org/drawingml/2006/main">
+              <a:ext uri="{FF2B5EF4-FFF2-40B4-BE49-F238E27FC236}">
+                <a16:creationId xmlns:a16="http://schemas.microsoft.com/office/drawing/2014/main" id="{31303E1F-E6BC-444C-8D84-2071F6D62129}"/>
+              </a:ext>
+            </a:extLst>
+          </p:cNvPr>
+          <p:cNvSpPr>
+            <a:spLocks xmlns:a="http://schemas.openxmlformats.org/drawingml/2006/main" noGrp="1"/>
+          </p:cNvSpPr>
+          <p:nvPr/>
+        </p:nvSpPr>
+        <p:spPr>
+          <a:xfrm xmlns:a="http://schemas.openxmlformats.org/drawingml/2006/main">
+            <a:off x="841248" y="3822191"/>
+            <a:ext cx="3072384" cy="228600"/>
+          </a:xfrm>
+          <a:prstGeom xmlns:a="http://schemas.openxmlformats.org/drawingml/2006/main" prst="rect">
+            <a:avLst/>
+          </a:prstGeom>
+          <a:noFill xmlns:a="http://schemas.openxmlformats.org/drawingml/2006/main"/>
+        </p:spPr>
+        <p:txBody>
+          <a:bodyPr xmlns:a="http://schemas.openxmlformats.org/drawingml/2006/main" wrap="square" lIns="36576" tIns="18288" rIns="36576" bIns="18288" anchor="t">
+            <a:spAutoFit/>
+          </a:bodyPr>
+          <a:lstStyle xmlns:a="http://schemas.openxmlformats.org/drawingml/2006/main"/>
+          <a:p xmlns:a="http://schemas.openxmlformats.org/drawingml/2006/main">
+            <a:r>
+              <a:rPr sz="1200" b="1">
+                <a:solidFill>
+                  <a:srgbClr val="255B92"/>
+                </a:solidFill>
+                <a:latin typeface="Aptos"/>
+                <a:ea typeface="Aptos"/>
+                <a:cs typeface="Aptos"/>
+              </a:rPr>
+              <a:t>Why it matters</a:t>
+            </a:r>
+          </a:p>
+        </p:txBody>
+      </p:sp>
+      <p:sp>
+        <p:nvSpPr>
+          <p:cNvPr id="33" name="TextBox 32">
+            <a:extLst xmlns:a="http://schemas.openxmlformats.org/drawingml/2006/main">
+              <a:ext uri="{FF2B5EF4-FFF2-40B4-BE49-F238E27FC236}">
+                <a16:creationId xmlns:a16="http://schemas.microsoft.com/office/drawing/2014/main" id="{9EFC2BD6-48BF-4D7B-BF81-A0C1AD46EA48}"/>
+              </a:ext>
+            </a:extLst>
+          </p:cNvPr>
+          <p:cNvSpPr>
+            <a:spLocks xmlns:a="http://schemas.openxmlformats.org/drawingml/2006/main" noGrp="1"/>
+          </p:cNvSpPr>
+          <p:nvPr/>
+        </p:nvSpPr>
+        <p:spPr>
+          <a:xfrm xmlns:a="http://schemas.openxmlformats.org/drawingml/2006/main">
+            <a:off x="841248" y="4142231"/>
+            <a:ext cx="3072384" cy="822959"/>
+          </a:xfrm>
+          <a:prstGeom xmlns:a="http://schemas.openxmlformats.org/drawingml/2006/main" prst="rect">
+            <a:avLst/>
+          </a:prstGeom>
+          <a:noFill xmlns:a="http://schemas.openxmlformats.org/drawingml/2006/main"/>
+        </p:spPr>
+        <p:txBody>
+          <a:bodyPr xmlns:a="http://schemas.openxmlformats.org/drawingml/2006/main" wrap="square" lIns="36576" tIns="18288" rIns="36576" bIns="18288" anchor="t">
+            <a:spAutoFit/>
+          </a:bodyPr>
+          <a:lstStyle xmlns:a="http://schemas.openxmlformats.org/drawingml/2006/main"/>
+          <a:p xmlns:a="http://schemas.openxmlformats.org/drawingml/2006/main">
+            <a:r>
+              <a:rPr sz="1080" b="0">
+                <a:solidFill>
+                  <a:srgbClr val="122026"/>
+                </a:solidFill>
+                <a:latin typeface="Aptos"/>
+                <a:ea typeface="Aptos"/>
+                <a:cs typeface="Aptos"/>
+              </a:rPr>
+              <a:t>The system no longer treats every question the same; it adapts its workflow to the user's actual intent.</a:t>
+            </a:r>
+          </a:p>
+        </p:txBody>
+      </p:sp>
+      <p:sp>
+        <p:nvSpPr>
+          <p:cNvPr id="34" name="Rounded Rectangle 33">
+            <a:extLst xmlns:a="http://schemas.openxmlformats.org/drawingml/2006/main">
+              <a:ext uri="{FF2B5EF4-FFF2-40B4-BE49-F238E27FC236}">
+                <a16:creationId xmlns:a16="http://schemas.microsoft.com/office/drawing/2014/main" id="{48129C2A-F1A7-41C1-88FE-1F9D8F78C9A4}"/>
+              </a:ext>
+            </a:extLst>
+          </p:cNvPr>
+          <p:cNvSpPr>
+            <a:spLocks xmlns:a="http://schemas.openxmlformats.org/drawingml/2006/main" noGrp="1"/>
+          </p:cNvSpPr>
+          <p:nvPr/>
+        </p:nvSpPr>
+        <p:spPr>
+          <a:xfrm xmlns:a="http://schemas.openxmlformats.org/drawingml/2006/main">
+            <a:off x="4434840" y="3703320"/>
+            <a:ext cx="3383280" cy="1325880"/>
+          </a:xfrm>
+          <a:prstGeom xmlns:a="http://schemas.openxmlformats.org/drawingml/2006/main" prst="roundRect">
+            <a:avLst/>
+          </a:prstGeom>
+          <a:solidFill xmlns:a="http://schemas.openxmlformats.org/drawingml/2006/main">
+            <a:srgbClr val="FFFFFF"/>
+          </a:solidFill>
+          <a:ln xmlns:a="http://schemas.openxmlformats.org/drawingml/2006/main" w="12700">
+            <a:solidFill>
+              <a:srgbClr val="CFDADA"/>
+            </a:solidFill>
+          </a:ln>
+        </p:spPr>
+        <p:style>
+          <a:lnRef xmlns:a="http://schemas.openxmlformats.org/drawingml/2006/main" idx="1">
+            <a:schemeClr val="accent1"/>
+          </a:lnRef>
+          <a:fillRef xmlns:a="http://schemas.openxmlformats.org/drawingml/2006/main" idx="3">
+            <a:schemeClr val="accent1"/>
+          </a:fillRef>
+          <a:effectRef xmlns:a="http://schemas.openxmlformats.org/drawingml/2006/main" idx="2">
+            <a:schemeClr val="accent1"/>
+          </a:effectRef>
+          <a:fontRef xmlns:a="http://schemas.openxmlformats.org/drawingml/2006/main" idx="minor">
+            <a:schemeClr val="lt1"/>
+          </a:fontRef>
+        </p:style>
+        <p:txBody>
+          <a:bodyPr xmlns:a="http://schemas.openxmlformats.org/drawingml/2006/main" anchor="ctr"/>
+          <a:lstStyle xmlns:a="http://schemas.openxmlformats.org/drawingml/2006/main"/>
+          <a:p xmlns:a="http://schemas.openxmlformats.org/drawingml/2006/main">
+            <a:pPr algn="ctr">
+              <a:buNone/>
+            </a:pPr>
+          </a:p>
+        </p:txBody>
+      </p:sp>
+      <p:sp>
+        <p:nvSpPr>
+          <p:cNvPr id="35" name="TextBox 34">
+            <a:extLst xmlns:a="http://schemas.openxmlformats.org/drawingml/2006/main">
+              <a:ext uri="{FF2B5EF4-FFF2-40B4-BE49-F238E27FC236}">
+                <a16:creationId xmlns:a16="http://schemas.microsoft.com/office/drawing/2014/main" id="{C988E3A0-2262-458D-9048-AE80EFCFECDE}"/>
+              </a:ext>
+            </a:extLst>
+          </p:cNvPr>
+          <p:cNvSpPr>
+            <a:spLocks xmlns:a="http://schemas.openxmlformats.org/drawingml/2006/main" noGrp="1"/>
+          </p:cNvSpPr>
+          <p:nvPr/>
+        </p:nvSpPr>
+        <p:spPr>
+          <a:xfrm xmlns:a="http://schemas.openxmlformats.org/drawingml/2006/main">
+            <a:off x="4590288" y="3822191"/>
+            <a:ext cx="3072384" cy="228600"/>
+          </a:xfrm>
+          <a:prstGeom xmlns:a="http://schemas.openxmlformats.org/drawingml/2006/main" prst="rect">
+            <a:avLst/>
+          </a:prstGeom>
+          <a:noFill xmlns:a="http://schemas.openxmlformats.org/drawingml/2006/main"/>
+        </p:spPr>
+        <p:txBody>
+          <a:bodyPr xmlns:a="http://schemas.openxmlformats.org/drawingml/2006/main" wrap="square" lIns="36576" tIns="18288" rIns="36576" bIns="18288" anchor="t">
+            <a:spAutoFit/>
+          </a:bodyPr>
+          <a:lstStyle xmlns:a="http://schemas.openxmlformats.org/drawingml/2006/main"/>
+          <a:p xmlns:a="http://schemas.openxmlformats.org/drawingml/2006/main">
+            <a:r>
+              <a:rPr sz="1200" b="1">
+                <a:solidFill>
+                  <a:srgbClr val="117A65"/>
+                </a:solidFill>
+                <a:latin typeface="Aptos"/>
+                <a:ea typeface="Aptos"/>
+                <a:cs typeface="Aptos"/>
+              </a:rPr>
+              <a:t>What changed in code</a:t>
+            </a:r>
+          </a:p>
+        </p:txBody>
+      </p:sp>
+      <p:sp>
+        <p:nvSpPr>
+          <p:cNvPr id="36" name="TextBox 35">
+            <a:extLst xmlns:a="http://schemas.openxmlformats.org/drawingml/2006/main">
+              <a:ext uri="{FF2B5EF4-FFF2-40B4-BE49-F238E27FC236}">
+                <a16:creationId xmlns:a16="http://schemas.microsoft.com/office/drawing/2014/main" id="{807BC573-EF31-4994-93CC-646F2B7CD3C1}"/>
+              </a:ext>
+            </a:extLst>
+          </p:cNvPr>
+          <p:cNvSpPr>
+            <a:spLocks xmlns:a="http://schemas.openxmlformats.org/drawingml/2006/main" noGrp="1"/>
+          </p:cNvSpPr>
+          <p:nvPr/>
+        </p:nvSpPr>
+        <p:spPr>
+          <a:xfrm xmlns:a="http://schemas.openxmlformats.org/drawingml/2006/main">
+            <a:off x="4590288" y="4142231"/>
+            <a:ext cx="3072384" cy="822959"/>
+          </a:xfrm>
+          <a:prstGeom xmlns:a="http://schemas.openxmlformats.org/drawingml/2006/main" prst="rect">
+            <a:avLst/>
+          </a:prstGeom>
+          <a:noFill xmlns:a="http://schemas.openxmlformats.org/drawingml/2006/main"/>
+        </p:spPr>
+        <p:txBody>
+          <a:bodyPr xmlns:a="http://schemas.openxmlformats.org/drawingml/2006/main" wrap="square" lIns="36576" tIns="18288" rIns="36576" bIns="18288" anchor="t">
+            <a:spAutoFit/>
+          </a:bodyPr>
+          <a:lstStyle xmlns:a="http://schemas.openxmlformats.org/drawingml/2006/main"/>
+          <a:p xmlns:a="http://schemas.openxmlformats.org/drawingml/2006/main">
+            <a:r>
+              <a:rPr sz="1080" b="0">
+                <a:solidFill>
+                  <a:srgbClr val="122026"/>
+                </a:solidFill>
+                <a:latin typeface="Aptos"/>
+                <a:ea typeface="Aptos"/>
+                <a:cs typeface="Aptos"/>
+              </a:rPr>
+              <a:t>Added agents/query_intelligence.py and wired query_profile through OrchestratorAgent and /api/ask.</a:t>
+            </a:r>
+          </a:p>
+        </p:txBody>
+      </p:sp>
+      <p:sp>
+        <p:nvSpPr>
+          <p:cNvPr id="37" name="Rounded Rectangle 36">
+            <a:extLst xmlns:a="http://schemas.openxmlformats.org/drawingml/2006/main">
+              <a:ext uri="{FF2B5EF4-FFF2-40B4-BE49-F238E27FC236}">
+                <a16:creationId xmlns:a16="http://schemas.microsoft.com/office/drawing/2014/main" id="{B344A3A7-76F5-49BD-8A45-053E190865D1}"/>
+              </a:ext>
+            </a:extLst>
+          </p:cNvPr>
+          <p:cNvSpPr>
+            <a:spLocks xmlns:a="http://schemas.openxmlformats.org/drawingml/2006/main" noGrp="1"/>
+          </p:cNvSpPr>
+          <p:nvPr/>
+        </p:nvSpPr>
+        <p:spPr>
+          <a:xfrm xmlns:a="http://schemas.openxmlformats.org/drawingml/2006/main">
+            <a:off x="8183879" y="3703320"/>
+            <a:ext cx="2834640" cy="1325880"/>
+          </a:xfrm>
+          <a:prstGeom xmlns:a="http://schemas.openxmlformats.org/drawingml/2006/main" prst="roundRect">
+            <a:avLst/>
+          </a:prstGeom>
+          <a:solidFill xmlns:a="http://schemas.openxmlformats.org/drawingml/2006/main">
+            <a:srgbClr val="FFFFFF"/>
+          </a:solidFill>
+          <a:ln xmlns:a="http://schemas.openxmlformats.org/drawingml/2006/main" w="12700">
+            <a:solidFill>
+              <a:srgbClr val="CFDADA"/>
+            </a:solidFill>
+          </a:ln>
+        </p:spPr>
+        <p:style>
+          <a:lnRef xmlns:a="http://schemas.openxmlformats.org/drawingml/2006/main" idx="1">
+            <a:schemeClr val="accent1"/>
+          </a:lnRef>
+          <a:fillRef xmlns:a="http://schemas.openxmlformats.org/drawingml/2006/main" idx="3">
+            <a:schemeClr val="accent1"/>
+          </a:fillRef>
+          <a:effectRef xmlns:a="http://schemas.openxmlformats.org/drawingml/2006/main" idx="2">
+            <a:schemeClr val="accent1"/>
+          </a:effectRef>
+          <a:fontRef xmlns:a="http://schemas.openxmlformats.org/drawingml/2006/main" idx="minor">
+            <a:schemeClr val="lt1"/>
+          </a:fontRef>
+        </p:style>
+        <p:txBody>
+          <a:bodyPr xmlns:a="http://schemas.openxmlformats.org/drawingml/2006/main" anchor="ctr"/>
+          <a:lstStyle xmlns:a="http://schemas.openxmlformats.org/drawingml/2006/main"/>
+          <a:p xmlns:a="http://schemas.openxmlformats.org/drawingml/2006/main">
+            <a:pPr algn="ctr">
+              <a:buNone/>
+            </a:pPr>
+          </a:p>
+        </p:txBody>
+      </p:sp>
+      <p:sp>
+        <p:nvSpPr>
+          <p:cNvPr id="38" name="TextBox 37">
+            <a:extLst xmlns:a="http://schemas.openxmlformats.org/drawingml/2006/main">
+              <a:ext uri="{FF2B5EF4-FFF2-40B4-BE49-F238E27FC236}">
+                <a16:creationId xmlns:a16="http://schemas.microsoft.com/office/drawing/2014/main" id="{9DE36345-9569-49B1-801E-D52C559B22EE}"/>
+              </a:ext>
+            </a:extLst>
+          </p:cNvPr>
+          <p:cNvSpPr>
+            <a:spLocks xmlns:a="http://schemas.openxmlformats.org/drawingml/2006/main" noGrp="1"/>
+          </p:cNvSpPr>
+          <p:nvPr/>
+        </p:nvSpPr>
+        <p:spPr>
+          <a:xfrm xmlns:a="http://schemas.openxmlformats.org/drawingml/2006/main">
+            <a:off x="8339327" y="3822191"/>
+            <a:ext cx="2523744" cy="228600"/>
+          </a:xfrm>
+          <a:prstGeom xmlns:a="http://schemas.openxmlformats.org/drawingml/2006/main" prst="rect">
+            <a:avLst/>
+          </a:prstGeom>
+          <a:noFill xmlns:a="http://schemas.openxmlformats.org/drawingml/2006/main"/>
+        </p:spPr>
+        <p:txBody>
+          <a:bodyPr xmlns:a="http://schemas.openxmlformats.org/drawingml/2006/main" wrap="square" lIns="36576" tIns="18288" rIns="36576" bIns="18288" anchor="t">
+            <a:spAutoFit/>
+          </a:bodyPr>
+          <a:lstStyle xmlns:a="http://schemas.openxmlformats.org/drawingml/2006/main"/>
+          <a:p xmlns:a="http://schemas.openxmlformats.org/drawingml/2006/main">
+            <a:r>
+              <a:rPr sz="1200" b="1">
+                <a:solidFill>
+                  <a:srgbClr val="255B92"/>
+                </a:solidFill>
+                <a:latin typeface="Aptos"/>
+                <a:ea typeface="Aptos"/>
+                <a:cs typeface="Aptos"/>
+              </a:rPr>
+              <a:t>Product impact</a:t>
+            </a:r>
+          </a:p>
+        </p:txBody>
+      </p:sp>
+      <p:sp>
+        <p:nvSpPr>
+          <p:cNvPr id="39" name="TextBox 38">
+            <a:extLst xmlns:a="http://schemas.openxmlformats.org/drawingml/2006/main">
+              <a:ext uri="{FF2B5EF4-FFF2-40B4-BE49-F238E27FC236}">
+                <a16:creationId xmlns:a16="http://schemas.microsoft.com/office/drawing/2014/main" id="{4E4E7544-F973-4586-8A6A-43B55714E1F0}"/>
+              </a:ext>
+            </a:extLst>
+          </p:cNvPr>
+          <p:cNvSpPr>
+            <a:spLocks xmlns:a="http://schemas.openxmlformats.org/drawingml/2006/main" noGrp="1"/>
+          </p:cNvSpPr>
+          <p:nvPr/>
+        </p:nvSpPr>
+        <p:spPr>
+          <a:xfrm xmlns:a="http://schemas.openxmlformats.org/drawingml/2006/main">
+            <a:off x="8339327" y="4142231"/>
+            <a:ext cx="2523744" cy="822959"/>
+          </a:xfrm>
+          <a:prstGeom xmlns:a="http://schemas.openxmlformats.org/drawingml/2006/main" prst="rect">
+            <a:avLst/>
+          </a:prstGeom>
+          <a:noFill xmlns:a="http://schemas.openxmlformats.org/drawingml/2006/main"/>
+        </p:spPr>
+        <p:txBody>
+          <a:bodyPr xmlns:a="http://schemas.openxmlformats.org/drawingml/2006/main" wrap="square" lIns="36576" tIns="18288" rIns="36576" bIns="18288" anchor="t">
+            <a:spAutoFit/>
+          </a:bodyPr>
+          <a:lstStyle xmlns:a="http://schemas.openxmlformats.org/drawingml/2006/main"/>
+          <a:p xmlns:a="http://schemas.openxmlformats.org/drawingml/2006/main">
+            <a:r>
+              <a:rPr sz="1080" b="0">
+                <a:solidFill>
+                  <a:srgbClr val="122026"/>
+                </a:solidFill>
+                <a:latin typeface="Aptos"/>
+                <a:ea typeface="Aptos"/>
+                <a:cs typeface="Aptos"/>
+              </a:rPr>
+              <a:t>Users see intent, risk preference, horizon, and confidence, which makes the assistant feel more transparent and startup-ready.</a:t>
+            </a:r>
+          </a:p>
+        </p:txBody>
+      </p:sp>
+    </p:spTree>
+    <p:extLst>
+      <p:ext uri="{BB962C8B-B14F-4D97-AF65-F5344CB8AC3E}">
+        <p14:creationId xmlns:p14="http://schemas.microsoft.com/office/powerpoint/2010/main" val="1655559900"/>
       </p:ext>
     </p:extLst>
   </p:cSld>
@@ -27469,7 +29463,7 @@
           <p:nvPr/>
         </p:nvPicPr>
         <p:blipFill>
-          <a:blip xmlns:r="http://schemas.openxmlformats.org/officeDocument/2006/relationships" xmlns:a="http://schemas.openxmlformats.org/drawingml/2006/main" r:embed="R3f0e929b98df4290"/>
+          <a:blip xmlns:r="http://schemas.openxmlformats.org/officeDocument/2006/relationships" xmlns:a="http://schemas.openxmlformats.org/drawingml/2006/main" r:embed="R1608643a945444b1"/>
           <a:stretch xmlns:a="http://schemas.openxmlformats.org/drawingml/2006/main">
             <a:fillRect l="0" t="0" r="0" b="0"/>
           </a:stretch>

</xml_diff>

<commit_message>
Add portfolio-aware ask UX and mentor slides
</commit_message>
<xml_diff>
--- a/docs/Financial_Intelligence_Engine_Phase2_Review1_Mentor_Update.pptx
+++ b/docs/Financial_Intelligence_Engine_Phase2_Review1_Mentor_Update.pptx
@@ -27,6 +27,8 @@
     <p:sldId xmlns:r="http://schemas.openxmlformats.org/officeDocument/2006/relationships" id="272" r:id="Rdd6258fe0375433e"/>
     <p:sldId xmlns:r="http://schemas.openxmlformats.org/officeDocument/2006/relationships" id="273" r:id="R33495775323a4c8a"/>
     <p:sldId xmlns:r="http://schemas.openxmlformats.org/officeDocument/2006/relationships" id="274" r:id="R1b4dc52cf811453e"/>
+    <p:sldId xmlns:ns0="http://schemas.openxmlformats.org/officeDocument/2006/relationships" id="275" ns0:id="rId26"/>
+    <p:sldId xmlns:ns0="http://schemas.openxmlformats.org/officeDocument/2006/relationships" id="276" ns0:id="rId27"/>
   </p:sldIdLst>
   <p:sldSz cx="12192000" cy="6858000"/>
   <p:notesSz cx="6858000" cy="9144000"/>
@@ -26186,6 +26188,2259 @@
       </p:ext>
     </p:extLst>
   </p:cSld>
+</p:sld>
+</file>
+
+<file path=ppt/slides/slide20.xml><?xml version="1.0" encoding="utf-8"?>
+<p:sld xmlns:a="http://schemas.openxmlformats.org/drawingml/2006/main" xmlns:p="http://schemas.openxmlformats.org/presentationml/2006/main" xmlns:r="http://schemas.openxmlformats.org/officeDocument/2006/relationships">
+  <p:cSld>
+    <p:spTree>
+      <p:nvGrpSpPr>
+        <p:cNvPr id="1" name=""/>
+        <p:cNvGrpSpPr/>
+        <p:nvPr/>
+      </p:nvGrpSpPr>
+      <p:grpSpPr/>
+      <p:sp>
+        <p:nvSpPr>
+          <p:cNvPr id="2" name="TextBox 1"/>
+          <p:cNvSpPr txBox="1"/>
+          <p:nvPr/>
+        </p:nvSpPr>
+        <p:spPr>
+          <a:xfrm>
+            <a:off x="594360" y="310896"/>
+            <a:ext cx="2468880" cy="256032"/>
+          </a:xfrm>
+          <a:prstGeom prst="rect">
+            <a:avLst/>
+          </a:prstGeom>
+          <a:noFill/>
+        </p:spPr>
+        <p:txBody>
+          <a:bodyPr wrap="none" lIns="36576" rIns="36576" tIns="18288" bIns="18288" anchor="t">
+            <a:spAutoFit/>
+          </a:bodyPr>
+          <a:lstStyle/>
+          <a:p>
+            <a:pPr algn="l"/>
+            <a:r>
+              <a:rPr sz="1100" b="1">
+                <a:solidFill>
+                  <a:srgbClr val="128466"/>
+                </a:solidFill>
+                <a:latin typeface="Aptos"/>
+              </a:rPr>
+              <a:t>ASK EXPERIENCE UPGRADE</a:t>
+            </a:r>
+          </a:p>
+        </p:txBody>
+      </p:sp>
+      <p:sp>
+        <p:nvSpPr>
+          <p:cNvPr id="3" name="TextBox 2"/>
+          <p:cNvSpPr txBox="1"/>
+          <p:nvPr/>
+        </p:nvSpPr>
+        <p:spPr>
+          <a:xfrm>
+            <a:off x="594360" y="621792"/>
+            <a:ext cx="10149840" cy="475488"/>
+          </a:xfrm>
+          <a:prstGeom prst="rect">
+            <a:avLst/>
+          </a:prstGeom>
+          <a:noFill/>
+        </p:spPr>
+        <p:txBody>
+          <a:bodyPr wrap="none" lIns="36576" rIns="36576" tIns="18288" bIns="18288" anchor="t">
+            <a:spAutoFit/>
+          </a:bodyPr>
+          <a:lstStyle/>
+          <a:p>
+            <a:pPr algn="l"/>
+            <a:r>
+              <a:rPr sz="2800" b="1">
+                <a:solidFill>
+                  <a:srgbClr val="12201C"/>
+                </a:solidFill>
+                <a:latin typeface="Aptos"/>
+              </a:rPr>
+              <a:t>The chat now answers like a product, not an internal report.</a:t>
+            </a:r>
+          </a:p>
+        </p:txBody>
+      </p:sp>
+      <p:sp>
+        <p:nvSpPr>
+          <p:cNvPr id="4" name="TextBox 3"/>
+          <p:cNvSpPr txBox="1"/>
+          <p:nvPr/>
+        </p:nvSpPr>
+        <p:spPr>
+          <a:xfrm>
+            <a:off x="612648" y="1097280"/>
+            <a:ext cx="9966960" cy="347472"/>
+          </a:xfrm>
+          <a:prstGeom prst="rect">
+            <a:avLst/>
+          </a:prstGeom>
+          <a:noFill/>
+        </p:spPr>
+        <p:txBody>
+          <a:bodyPr wrap="none" lIns="36576" rIns="36576" tIns="18288" bIns="18288" anchor="t">
+            <a:spAutoFit/>
+          </a:bodyPr>
+          <a:lstStyle/>
+          <a:p>
+            <a:pPr algn="l"/>
+            <a:r>
+              <a:rPr sz="1400" b="0">
+                <a:solidFill>
+                  <a:srgbClr val="586962"/>
+                </a:solidFill>
+                <a:latin typeface="Aptos"/>
+              </a:rPr>
+              <a:t>Phase 2 improvement converts raw agent output into clear user actions, portfolio context, and safer next steps.</a:t>
+            </a:r>
+          </a:p>
+        </p:txBody>
+      </p:sp>
+      <p:sp>
+        <p:nvSpPr>
+          <p:cNvPr id="5" name="Rectangle 4"/>
+          <p:cNvSpPr/>
+          <p:nvPr/>
+        </p:nvSpPr>
+        <p:spPr>
+          <a:xfrm>
+            <a:off x="594360" y="1527048"/>
+            <a:ext cx="10241280" cy="18288"/>
+          </a:xfrm>
+          <a:prstGeom prst="rect">
+            <a:avLst/>
+          </a:prstGeom>
+          <a:solidFill>
+            <a:srgbClr val="C7DBD2"/>
+          </a:solidFill>
+          <a:ln>
+            <a:solidFill>
+              <a:srgbClr val="C7DBD2"/>
+            </a:solidFill>
+          </a:ln>
+        </p:spPr>
+        <p:style>
+          <a:lnRef idx="1">
+            <a:schemeClr val="accent1"/>
+          </a:lnRef>
+          <a:fillRef idx="3">
+            <a:schemeClr val="accent1"/>
+          </a:fillRef>
+          <a:effectRef idx="2">
+            <a:schemeClr val="accent1"/>
+          </a:effectRef>
+          <a:fontRef idx="minor">
+            <a:schemeClr val="lt1"/>
+          </a:fontRef>
+        </p:style>
+        <p:txBody>
+          <a:bodyPr rtlCol="0" anchor="ctr"/>
+          <a:lstStyle/>
+          <a:p>
+            <a:pPr algn="ctr"/>
+          </a:p>
+        </p:txBody>
+      </p:sp>
+      <p:sp>
+        <p:nvSpPr>
+          <p:cNvPr id="6" name="Rounded Rectangle 5"/>
+          <p:cNvSpPr/>
+          <p:nvPr/>
+        </p:nvSpPr>
+        <p:spPr>
+          <a:xfrm>
+            <a:off x="594360" y="1783080"/>
+            <a:ext cx="4892040" cy="3611880"/>
+          </a:xfrm>
+          <a:prstGeom prst="roundRect">
+            <a:avLst/>
+          </a:prstGeom>
+          <a:solidFill>
+            <a:srgbClr val="FDFDFC"/>
+          </a:solidFill>
+          <a:ln w="12700">
+            <a:solidFill>
+              <a:srgbClr val="C7DBD2"/>
+            </a:solidFill>
+          </a:ln>
+        </p:spPr>
+        <p:style>
+          <a:lnRef idx="1">
+            <a:schemeClr val="accent1"/>
+          </a:lnRef>
+          <a:fillRef idx="3">
+            <a:schemeClr val="accent1"/>
+          </a:fillRef>
+          <a:effectRef idx="2">
+            <a:schemeClr val="accent1"/>
+          </a:effectRef>
+          <a:fontRef idx="minor">
+            <a:schemeClr val="lt1"/>
+          </a:fontRef>
+        </p:style>
+        <p:txBody>
+          <a:bodyPr rtlCol="0" anchor="ctr"/>
+          <a:lstStyle/>
+          <a:p>
+            <a:pPr algn="ctr"/>
+          </a:p>
+        </p:txBody>
+      </p:sp>
+      <p:sp>
+        <p:nvSpPr>
+          <p:cNvPr id="7" name="TextBox 6"/>
+          <p:cNvSpPr txBox="1"/>
+          <p:nvPr/>
+        </p:nvSpPr>
+        <p:spPr>
+          <a:xfrm>
+            <a:off x="822960" y="1993392"/>
+            <a:ext cx="1097280" cy="274320"/>
+          </a:xfrm>
+          <a:prstGeom prst="rect">
+            <a:avLst/>
+          </a:prstGeom>
+          <a:noFill/>
+        </p:spPr>
+        <p:txBody>
+          <a:bodyPr wrap="none" lIns="36576" rIns="36576" tIns="18288" bIns="18288" anchor="t">
+            <a:spAutoFit/>
+          </a:bodyPr>
+          <a:lstStyle/>
+          <a:p>
+            <a:pPr algn="l"/>
+            <a:r>
+              <a:rPr sz="1600" b="1">
+                <a:solidFill>
+                  <a:srgbClr val="975B20"/>
+                </a:solidFill>
+                <a:latin typeface="Aptos"/>
+              </a:rPr>
+              <a:t>Before</a:t>
+            </a:r>
+          </a:p>
+        </p:txBody>
+      </p:sp>
+      <p:sp>
+        <p:nvSpPr>
+          <p:cNvPr id="8" name="TextBox 7"/>
+          <p:cNvSpPr txBox="1"/>
+          <p:nvPr/>
+        </p:nvSpPr>
+        <p:spPr>
+          <a:xfrm>
+            <a:off x="822960" y="2395728"/>
+            <a:ext cx="4343400" cy="2148840"/>
+          </a:xfrm>
+          <a:prstGeom prst="rect">
+            <a:avLst/>
+          </a:prstGeom>
+          <a:noFill/>
+        </p:spPr>
+        <p:txBody>
+          <a:bodyPr wrap="none" lIns="73152" rIns="36576" tIns="36576" bIns="36576">
+            <a:spAutoFit/>
+          </a:bodyPr>
+          <a:lstStyle/>
+          <a:p>
+            <a:pPr>
+              <a:spcAft>
+                <a:spcPts val="800"/>
+              </a:spcAft>
+              <a:defRPr sz="1500">
+                <a:solidFill>
+                  <a:srgbClr val="586962"/>
+                </a:solidFill>
+                <a:latin typeface="Aptos"/>
+              </a:defRPr>
+            </a:pPr>
+            <a:r>
+              <a:t>Displayed technical routing and formulas in the main answer.</a:t>
+            </a:r>
+          </a:p>
+          <a:p>
+            <a:pPr>
+              <a:spcAft>
+                <a:spcPts val="800"/>
+              </a:spcAft>
+              <a:defRPr sz="1500">
+                <a:solidFill>
+                  <a:srgbClr val="586962"/>
+                </a:solidFill>
+                <a:latin typeface="Aptos"/>
+              </a:defRPr>
+            </a:pPr>
+            <a:r>
+              <a:t>Hold signals looked like direct investment instructions.</a:t>
+            </a:r>
+          </a:p>
+          <a:p>
+            <a:pPr>
+              <a:spcAft>
+                <a:spcPts val="800"/>
+              </a:spcAft>
+              <a:defRPr sz="1500">
+                <a:solidFill>
+                  <a:srgbClr val="586962"/>
+                </a:solidFill>
+                <a:latin typeface="Aptos"/>
+              </a:defRPr>
+            </a:pPr>
+            <a:r>
+              <a:t>User could not see their current portfolio or concentration risk.</a:t>
+            </a:r>
+          </a:p>
+          <a:p>
+            <a:pPr>
+              <a:spcAft>
+                <a:spcPts val="800"/>
+              </a:spcAft>
+              <a:defRPr sz="1500">
+                <a:solidFill>
+                  <a:srgbClr val="586962"/>
+                </a:solidFill>
+                <a:latin typeface="Aptos"/>
+              </a:defRPr>
+            </a:pPr>
+            <a:r>
+              <a:t>Important answer was mixed with raw retrieved report text.</a:t>
+            </a:r>
+          </a:p>
+        </p:txBody>
+      </p:sp>
+      <p:sp>
+        <p:nvSpPr>
+          <p:cNvPr id="9" name="Rounded Rectangle 8"/>
+          <p:cNvSpPr/>
+          <p:nvPr/>
+        </p:nvSpPr>
+        <p:spPr>
+          <a:xfrm>
+            <a:off x="5715000" y="1783080"/>
+            <a:ext cx="4892040" cy="3611880"/>
+          </a:xfrm>
+          <a:prstGeom prst="roundRect">
+            <a:avLst/>
+          </a:prstGeom>
+          <a:solidFill>
+            <a:srgbClr val="EEF7F3"/>
+          </a:solidFill>
+          <a:ln w="12700">
+            <a:solidFill>
+              <a:srgbClr val="C7DBD2"/>
+            </a:solidFill>
+          </a:ln>
+        </p:spPr>
+        <p:style>
+          <a:lnRef idx="1">
+            <a:schemeClr val="accent1"/>
+          </a:lnRef>
+          <a:fillRef idx="3">
+            <a:schemeClr val="accent1"/>
+          </a:fillRef>
+          <a:effectRef idx="2">
+            <a:schemeClr val="accent1"/>
+          </a:effectRef>
+          <a:fontRef idx="minor">
+            <a:schemeClr val="lt1"/>
+          </a:fontRef>
+        </p:style>
+        <p:txBody>
+          <a:bodyPr rtlCol="0" anchor="ctr"/>
+          <a:lstStyle/>
+          <a:p>
+            <a:pPr algn="ctr"/>
+          </a:p>
+        </p:txBody>
+      </p:sp>
+      <p:sp>
+        <p:nvSpPr>
+          <p:cNvPr id="10" name="TextBox 9"/>
+          <p:cNvSpPr txBox="1"/>
+          <p:nvPr/>
+        </p:nvSpPr>
+        <p:spPr>
+          <a:xfrm>
+            <a:off x="5943600" y="1993392"/>
+            <a:ext cx="1005840" cy="274320"/>
+          </a:xfrm>
+          <a:prstGeom prst="rect">
+            <a:avLst/>
+          </a:prstGeom>
+          <a:noFill/>
+        </p:spPr>
+        <p:txBody>
+          <a:bodyPr wrap="none" lIns="36576" rIns="36576" tIns="18288" bIns="18288" anchor="t">
+            <a:spAutoFit/>
+          </a:bodyPr>
+          <a:lstStyle/>
+          <a:p>
+            <a:pPr algn="l"/>
+            <a:r>
+              <a:rPr sz="1600" b="1">
+                <a:solidFill>
+                  <a:srgbClr val="08483A"/>
+                </a:solidFill>
+                <a:latin typeface="Aptos"/>
+              </a:rPr>
+              <a:t>Now</a:t>
+            </a:r>
+          </a:p>
+        </p:txBody>
+      </p:sp>
+      <p:sp>
+        <p:nvSpPr>
+          <p:cNvPr id="11" name="TextBox 10"/>
+          <p:cNvSpPr txBox="1"/>
+          <p:nvPr/>
+        </p:nvSpPr>
+        <p:spPr>
+          <a:xfrm>
+            <a:off x="5943600" y="2395728"/>
+            <a:ext cx="4343400" cy="2148840"/>
+          </a:xfrm>
+          <a:prstGeom prst="rect">
+            <a:avLst/>
+          </a:prstGeom>
+          <a:noFill/>
+        </p:spPr>
+        <p:txBody>
+          <a:bodyPr wrap="none" lIns="73152" rIns="36576" tIns="36576" bIns="36576">
+            <a:spAutoFit/>
+          </a:bodyPr>
+          <a:lstStyle/>
+          <a:p>
+            <a:pPr>
+              <a:spcAft>
+                <a:spcPts val="800"/>
+              </a:spcAft>
+              <a:defRPr sz="1500">
+                <a:solidFill>
+                  <a:srgbClr val="12201C"/>
+                </a:solidFill>
+                <a:latin typeface="Aptos"/>
+              </a:defRPr>
+            </a:pPr>
+            <a:r>
+              <a:t>What You Should Do: reserve cash + staged action.</a:t>
+            </a:r>
+          </a:p>
+          <a:p>
+            <a:pPr>
+              <a:spcAft>
+                <a:spcPts val="800"/>
+              </a:spcAft>
+              <a:defRPr sz="1500">
+                <a:solidFill>
+                  <a:srgbClr val="12201C"/>
+                </a:solidFill>
+                <a:latin typeface="Aptos"/>
+              </a:defRPr>
+            </a:pPr>
+            <a:r>
+              <a:t>Where To Invest: dollar allocation by ticker.</a:t>
+            </a:r>
+          </a:p>
+          <a:p>
+            <a:pPr>
+              <a:spcAft>
+                <a:spcPts val="800"/>
+              </a:spcAft>
+              <a:defRPr sz="1500">
+                <a:solidFill>
+                  <a:srgbClr val="12201C"/>
+                </a:solidFill>
+                <a:latin typeface="Aptos"/>
+              </a:defRPr>
+            </a:pPr>
+            <a:r>
+              <a:t>Your Current Portfolio: optional holdings and overlap warnings.</a:t>
+            </a:r>
+          </a:p>
+          <a:p>
+            <a:pPr>
+              <a:spcAft>
+                <a:spcPts val="800"/>
+              </a:spcAft>
+              <a:defRPr sz="1500">
+                <a:solidFill>
+                  <a:srgbClr val="12201C"/>
+                </a:solidFill>
+                <a:latin typeface="Aptos"/>
+              </a:defRPr>
+            </a:pPr>
+            <a:r>
+              <a:t>Technical trace is collapsed for mentor/examiner inspection.</a:t>
+            </a:r>
+          </a:p>
+        </p:txBody>
+      </p:sp>
+      <p:sp>
+        <p:nvSpPr>
+          <p:cNvPr id="12" name="Rounded Rectangle 11"/>
+          <p:cNvSpPr/>
+          <p:nvPr/>
+        </p:nvSpPr>
+        <p:spPr>
+          <a:xfrm>
+            <a:off x="914400" y="4892040"/>
+            <a:ext cx="1463040" cy="310896"/>
+          </a:xfrm>
+          <a:prstGeom prst="roundRect">
+            <a:avLst/>
+          </a:prstGeom>
+          <a:solidFill>
+            <a:srgbClr val="E5EEF8"/>
+          </a:solidFill>
+          <a:ln w="12700">
+            <a:solidFill>
+              <a:srgbClr val="E5EEF8"/>
+            </a:solidFill>
+          </a:ln>
+        </p:spPr>
+        <p:style>
+          <a:lnRef idx="1">
+            <a:schemeClr val="accent1"/>
+          </a:lnRef>
+          <a:fillRef idx="3">
+            <a:schemeClr val="accent1"/>
+          </a:fillRef>
+          <a:effectRef idx="2">
+            <a:schemeClr val="accent1"/>
+          </a:effectRef>
+          <a:fontRef idx="minor">
+            <a:schemeClr val="lt1"/>
+          </a:fontRef>
+        </p:style>
+        <p:txBody>
+          <a:bodyPr rtlCol="0" anchor="ctr"/>
+          <a:lstStyle/>
+          <a:p>
+            <a:pPr algn="ctr"/>
+          </a:p>
+        </p:txBody>
+      </p:sp>
+      <p:sp>
+        <p:nvSpPr>
+          <p:cNvPr id="13" name="TextBox 12"/>
+          <p:cNvSpPr txBox="1"/>
+          <p:nvPr/>
+        </p:nvSpPr>
+        <p:spPr>
+          <a:xfrm>
+            <a:off x="987552" y="4956048"/>
+            <a:ext cx="1316736" cy="146304"/>
+          </a:xfrm>
+          <a:prstGeom prst="rect">
+            <a:avLst/>
+          </a:prstGeom>
+          <a:noFill/>
+        </p:spPr>
+        <p:txBody>
+          <a:bodyPr wrap="none" lIns="36576" rIns="36576" tIns="18288" bIns="18288" anchor="t">
+            <a:spAutoFit/>
+          </a:bodyPr>
+          <a:lstStyle/>
+          <a:p>
+            <a:pPr algn="ctr"/>
+            <a:r>
+              <a:rPr sz="1000" b="1">
+                <a:solidFill>
+                  <a:srgbClr val="2B5E94"/>
+                </a:solidFill>
+                <a:latin typeface="Aptos"/>
+              </a:rPr>
+              <a:t>frontend/index.html</a:t>
+            </a:r>
+          </a:p>
+        </p:txBody>
+      </p:sp>
+      <p:sp>
+        <p:nvSpPr>
+          <p:cNvPr id="14" name="Rounded Rectangle 13"/>
+          <p:cNvSpPr/>
+          <p:nvPr/>
+        </p:nvSpPr>
+        <p:spPr>
+          <a:xfrm>
+            <a:off x="2514600" y="4892040"/>
+            <a:ext cx="1325880" cy="310896"/>
+          </a:xfrm>
+          <a:prstGeom prst="roundRect">
+            <a:avLst/>
+          </a:prstGeom>
+          <a:solidFill>
+            <a:srgbClr val="E5EEF8"/>
+          </a:solidFill>
+          <a:ln w="12700">
+            <a:solidFill>
+              <a:srgbClr val="E5EEF8"/>
+            </a:solidFill>
+          </a:ln>
+        </p:spPr>
+        <p:style>
+          <a:lnRef idx="1">
+            <a:schemeClr val="accent1"/>
+          </a:lnRef>
+          <a:fillRef idx="3">
+            <a:schemeClr val="accent1"/>
+          </a:fillRef>
+          <a:effectRef idx="2">
+            <a:schemeClr val="accent1"/>
+          </a:effectRef>
+          <a:fontRef idx="minor">
+            <a:schemeClr val="lt1"/>
+          </a:fontRef>
+        </p:style>
+        <p:txBody>
+          <a:bodyPr rtlCol="0" anchor="ctr"/>
+          <a:lstStyle/>
+          <a:p>
+            <a:pPr algn="ctr"/>
+          </a:p>
+        </p:txBody>
+      </p:sp>
+      <p:sp>
+        <p:nvSpPr>
+          <p:cNvPr id="15" name="TextBox 14"/>
+          <p:cNvSpPr txBox="1"/>
+          <p:nvPr/>
+        </p:nvSpPr>
+        <p:spPr>
+          <a:xfrm>
+            <a:off x="2587752" y="4956048"/>
+            <a:ext cx="1179576" cy="146304"/>
+          </a:xfrm>
+          <a:prstGeom prst="rect">
+            <a:avLst/>
+          </a:prstGeom>
+          <a:noFill/>
+        </p:spPr>
+        <p:txBody>
+          <a:bodyPr wrap="none" lIns="36576" rIns="36576" tIns="18288" bIns="18288" anchor="t">
+            <a:spAutoFit/>
+          </a:bodyPr>
+          <a:lstStyle/>
+          <a:p>
+            <a:pPr algn="ctr"/>
+            <a:r>
+              <a:rPr sz="1000" b="1">
+                <a:solidFill>
+                  <a:srgbClr val="2B5E94"/>
+                </a:solidFill>
+                <a:latin typeface="Aptos"/>
+              </a:rPr>
+              <a:t>frontend/app.js</a:t>
+            </a:r>
+          </a:p>
+        </p:txBody>
+      </p:sp>
+      <p:sp>
+        <p:nvSpPr>
+          <p:cNvPr id="16" name="Rounded Rectangle 15"/>
+          <p:cNvSpPr/>
+          <p:nvPr/>
+        </p:nvSpPr>
+        <p:spPr>
+          <a:xfrm>
+            <a:off x="3977639" y="4892040"/>
+            <a:ext cx="1417320" cy="310896"/>
+          </a:xfrm>
+          <a:prstGeom prst="roundRect">
+            <a:avLst/>
+          </a:prstGeom>
+          <a:solidFill>
+            <a:srgbClr val="E5EEF8"/>
+          </a:solidFill>
+          <a:ln w="12700">
+            <a:solidFill>
+              <a:srgbClr val="E5EEF8"/>
+            </a:solidFill>
+          </a:ln>
+        </p:spPr>
+        <p:style>
+          <a:lnRef idx="1">
+            <a:schemeClr val="accent1"/>
+          </a:lnRef>
+          <a:fillRef idx="3">
+            <a:schemeClr val="accent1"/>
+          </a:fillRef>
+          <a:effectRef idx="2">
+            <a:schemeClr val="accent1"/>
+          </a:effectRef>
+          <a:fontRef idx="minor">
+            <a:schemeClr val="lt1"/>
+          </a:fontRef>
+        </p:style>
+        <p:txBody>
+          <a:bodyPr rtlCol="0" anchor="ctr"/>
+          <a:lstStyle/>
+          <a:p>
+            <a:pPr algn="ctr"/>
+          </a:p>
+        </p:txBody>
+      </p:sp>
+      <p:sp>
+        <p:nvSpPr>
+          <p:cNvPr id="17" name="TextBox 16"/>
+          <p:cNvSpPr txBox="1"/>
+          <p:nvPr/>
+        </p:nvSpPr>
+        <p:spPr>
+          <a:xfrm>
+            <a:off x="4050791" y="4956048"/>
+            <a:ext cx="1271016" cy="146304"/>
+          </a:xfrm>
+          <a:prstGeom prst="rect">
+            <a:avLst/>
+          </a:prstGeom>
+          <a:noFill/>
+        </p:spPr>
+        <p:txBody>
+          <a:bodyPr wrap="none" lIns="36576" rIns="36576" tIns="18288" bIns="18288" anchor="t">
+            <a:spAutoFit/>
+          </a:bodyPr>
+          <a:lstStyle/>
+          <a:p>
+            <a:pPr algn="ctr"/>
+            <a:r>
+              <a:rPr sz="1000" b="1">
+                <a:solidFill>
+                  <a:srgbClr val="2B5E94"/>
+                </a:solidFill>
+                <a:latin typeface="Aptos"/>
+              </a:rPr>
+              <a:t>frontend/server.py</a:t>
+            </a:r>
+          </a:p>
+        </p:txBody>
+      </p:sp>
+    </p:spTree>
+  </p:cSld>
+  <p:clrMapOvr>
+    <a:masterClrMapping/>
+  </p:clrMapOvr>
+</p:sld>
+</file>
+
+<file path=ppt/slides/slide21.xml><?xml version="1.0" encoding="utf-8"?>
+<p:sld xmlns:a="http://schemas.openxmlformats.org/drawingml/2006/main" xmlns:p="http://schemas.openxmlformats.org/presentationml/2006/main" xmlns:r="http://schemas.openxmlformats.org/officeDocument/2006/relationships">
+  <p:cSld>
+    <p:spTree>
+      <p:nvGrpSpPr>
+        <p:cNvPr id="1" name=""/>
+        <p:cNvGrpSpPr/>
+        <p:nvPr/>
+      </p:nvGrpSpPr>
+      <p:grpSpPr/>
+      <p:sp>
+        <p:nvSpPr>
+          <p:cNvPr id="2" name="TextBox 1"/>
+          <p:cNvSpPr txBox="1"/>
+          <p:nvPr/>
+        </p:nvSpPr>
+        <p:spPr>
+          <a:xfrm>
+            <a:off x="594360" y="310896"/>
+            <a:ext cx="2468880" cy="256032"/>
+          </a:xfrm>
+          <a:prstGeom prst="rect">
+            <a:avLst/>
+          </a:prstGeom>
+          <a:noFill/>
+        </p:spPr>
+        <p:txBody>
+          <a:bodyPr wrap="none" lIns="36576" rIns="36576" tIns="18288" bIns="18288" anchor="t">
+            <a:spAutoFit/>
+          </a:bodyPr>
+          <a:lstStyle/>
+          <a:p>
+            <a:pPr algn="l"/>
+            <a:r>
+              <a:rPr sz="1100" b="1">
+                <a:solidFill>
+                  <a:srgbClr val="128466"/>
+                </a:solidFill>
+                <a:latin typeface="Aptos"/>
+              </a:rPr>
+              <a:t>GUARDRAILS + PERFORMANCE</a:t>
+            </a:r>
+          </a:p>
+        </p:txBody>
+      </p:sp>
+      <p:sp>
+        <p:nvSpPr>
+          <p:cNvPr id="3" name="TextBox 2"/>
+          <p:cNvSpPr txBox="1"/>
+          <p:nvPr/>
+        </p:nvSpPr>
+        <p:spPr>
+          <a:xfrm>
+            <a:off x="594360" y="621792"/>
+            <a:ext cx="10149840" cy="475488"/>
+          </a:xfrm>
+          <a:prstGeom prst="rect">
+            <a:avLst/>
+          </a:prstGeom>
+          <a:noFill/>
+        </p:spPr>
+        <p:txBody>
+          <a:bodyPr wrap="none" lIns="36576" rIns="36576" tIns="18288" bIns="18288" anchor="t">
+            <a:spAutoFit/>
+          </a:bodyPr>
+          <a:lstStyle/>
+          <a:p>
+            <a:pPr algn="l"/>
+            <a:r>
+              <a:rPr sz="2800" b="1">
+                <a:solidFill>
+                  <a:srgbClr val="12201C"/>
+                </a:solidFill>
+                <a:latin typeface="Aptos"/>
+              </a:rPr>
+              <a:t>Portfolio-aware Ask flow is safer and faster for live review.</a:t>
+            </a:r>
+          </a:p>
+        </p:txBody>
+      </p:sp>
+      <p:sp>
+        <p:nvSpPr>
+          <p:cNvPr id="4" name="TextBox 3"/>
+          <p:cNvSpPr txBox="1"/>
+          <p:nvPr/>
+        </p:nvSpPr>
+        <p:spPr>
+          <a:xfrm>
+            <a:off x="612648" y="1097280"/>
+            <a:ext cx="9966960" cy="347472"/>
+          </a:xfrm>
+          <a:prstGeom prst="rect">
+            <a:avLst/>
+          </a:prstGeom>
+          <a:noFill/>
+        </p:spPr>
+        <p:txBody>
+          <a:bodyPr wrap="none" lIns="36576" rIns="36576" tIns="18288" bIns="18288" anchor="t">
+            <a:spAutoFit/>
+          </a:bodyPr>
+          <a:lstStyle/>
+          <a:p>
+            <a:pPr algn="l"/>
+            <a:r>
+              <a:rPr sz="1400" b="0">
+                <a:solidFill>
+                  <a:srgbClr val="586962"/>
+                </a:solidFill>
+                <a:latin typeface="Aptos"/>
+              </a:rPr>
+              <a:t>The assistant now parses holdings, avoids concentration, and exposes timings for every agent step.</a:t>
+            </a:r>
+          </a:p>
+        </p:txBody>
+      </p:sp>
+      <p:sp>
+        <p:nvSpPr>
+          <p:cNvPr id="5" name="Rectangle 4"/>
+          <p:cNvSpPr/>
+          <p:nvPr/>
+        </p:nvSpPr>
+        <p:spPr>
+          <a:xfrm>
+            <a:off x="594360" y="1527048"/>
+            <a:ext cx="10241280" cy="18288"/>
+          </a:xfrm>
+          <a:prstGeom prst="rect">
+            <a:avLst/>
+          </a:prstGeom>
+          <a:solidFill>
+            <a:srgbClr val="C7DBD2"/>
+          </a:solidFill>
+          <a:ln>
+            <a:solidFill>
+              <a:srgbClr val="C7DBD2"/>
+            </a:solidFill>
+          </a:ln>
+        </p:spPr>
+        <p:style>
+          <a:lnRef idx="1">
+            <a:schemeClr val="accent1"/>
+          </a:lnRef>
+          <a:fillRef idx="3">
+            <a:schemeClr val="accent1"/>
+          </a:fillRef>
+          <a:effectRef idx="2">
+            <a:schemeClr val="accent1"/>
+          </a:effectRef>
+          <a:fontRef idx="minor">
+            <a:schemeClr val="lt1"/>
+          </a:fontRef>
+        </p:style>
+        <p:txBody>
+          <a:bodyPr rtlCol="0" anchor="ctr"/>
+          <a:lstStyle/>
+          <a:p>
+            <a:pPr algn="ctr"/>
+          </a:p>
+        </p:txBody>
+      </p:sp>
+      <p:sp>
+        <p:nvSpPr>
+          <p:cNvPr id="6" name="Rounded Rectangle 5"/>
+          <p:cNvSpPr/>
+          <p:nvPr/>
+        </p:nvSpPr>
+        <p:spPr>
+          <a:xfrm>
+            <a:off x="685800" y="1828800"/>
+            <a:ext cx="2240280" cy="960120"/>
+          </a:xfrm>
+          <a:prstGeom prst="roundRect">
+            <a:avLst/>
+          </a:prstGeom>
+          <a:solidFill>
+            <a:srgbClr val="FFFFFF"/>
+          </a:solidFill>
+          <a:ln w="12700">
+            <a:solidFill>
+              <a:srgbClr val="C7DBD2"/>
+            </a:solidFill>
+          </a:ln>
+        </p:spPr>
+        <p:style>
+          <a:lnRef idx="1">
+            <a:schemeClr val="accent1"/>
+          </a:lnRef>
+          <a:fillRef idx="3">
+            <a:schemeClr val="accent1"/>
+          </a:fillRef>
+          <a:effectRef idx="2">
+            <a:schemeClr val="accent1"/>
+          </a:effectRef>
+          <a:fontRef idx="minor">
+            <a:schemeClr val="lt1"/>
+          </a:fontRef>
+        </p:style>
+        <p:txBody>
+          <a:bodyPr rtlCol="0" anchor="ctr"/>
+          <a:lstStyle/>
+          <a:p>
+            <a:pPr algn="ctr"/>
+          </a:p>
+        </p:txBody>
+      </p:sp>
+      <p:sp>
+        <p:nvSpPr>
+          <p:cNvPr id="7" name="TextBox 6"/>
+          <p:cNvSpPr txBox="1"/>
+          <p:nvPr/>
+        </p:nvSpPr>
+        <p:spPr>
+          <a:xfrm>
+            <a:off x="822960" y="1965960"/>
+            <a:ext cx="1920240" cy="228600"/>
+          </a:xfrm>
+          <a:prstGeom prst="rect">
+            <a:avLst/>
+          </a:prstGeom>
+          <a:noFill/>
+        </p:spPr>
+        <p:txBody>
+          <a:bodyPr wrap="none" lIns="36576" rIns="36576" tIns="18288" bIns="18288" anchor="t">
+            <a:spAutoFit/>
+          </a:bodyPr>
+          <a:lstStyle/>
+          <a:p>
+            <a:pPr algn="ctr"/>
+            <a:r>
+              <a:rPr sz="1500" b="1">
+                <a:solidFill>
+                  <a:srgbClr val="08483A"/>
+                </a:solidFill>
+                <a:latin typeface="Aptos"/>
+              </a:rPr>
+              <a:t>Question</a:t>
+            </a:r>
+          </a:p>
+        </p:txBody>
+      </p:sp>
+      <p:sp>
+        <p:nvSpPr>
+          <p:cNvPr id="8" name="TextBox 7"/>
+          <p:cNvSpPr txBox="1"/>
+          <p:nvPr/>
+        </p:nvSpPr>
+        <p:spPr>
+          <a:xfrm>
+            <a:off x="850392" y="2276856"/>
+            <a:ext cx="1874519" cy="292608"/>
+          </a:xfrm>
+          <a:prstGeom prst="rect">
+            <a:avLst/>
+          </a:prstGeom>
+          <a:noFill/>
+        </p:spPr>
+        <p:txBody>
+          <a:bodyPr wrap="none" lIns="36576" rIns="36576" tIns="18288" bIns="18288" anchor="t">
+            <a:spAutoFit/>
+          </a:bodyPr>
+          <a:lstStyle/>
+          <a:p>
+            <a:pPr algn="ctr"/>
+            <a:r>
+              <a:rPr sz="1050" b="0">
+                <a:solidFill>
+                  <a:srgbClr val="586962"/>
+                </a:solidFill>
+                <a:latin typeface="Aptos"/>
+              </a:rPr>
+              <a:t>Budget, risk style, horizon</a:t>
+            </a:r>
+          </a:p>
+        </p:txBody>
+      </p:sp>
+      <p:sp>
+        <p:nvSpPr>
+          <p:cNvPr id="9" name="TextBox 8"/>
+          <p:cNvSpPr txBox="1"/>
+          <p:nvPr/>
+        </p:nvSpPr>
+        <p:spPr>
+          <a:xfrm>
+            <a:off x="3017520" y="2139696"/>
+            <a:ext cx="320040" cy="228600"/>
+          </a:xfrm>
+          <a:prstGeom prst="rect">
+            <a:avLst/>
+          </a:prstGeom>
+          <a:noFill/>
+        </p:spPr>
+        <p:txBody>
+          <a:bodyPr wrap="none" lIns="36576" rIns="36576" tIns="18288" bIns="18288" anchor="t">
+            <a:spAutoFit/>
+          </a:bodyPr>
+          <a:lstStyle/>
+          <a:p>
+            <a:pPr algn="ctr"/>
+            <a:r>
+              <a:rPr sz="1800" b="1">
+                <a:solidFill>
+                  <a:srgbClr val="128466"/>
+                </a:solidFill>
+                <a:latin typeface="Aptos"/>
+              </a:rPr>
+              <a:t>-&gt;</a:t>
+            </a:r>
+          </a:p>
+        </p:txBody>
+      </p:sp>
+      <p:sp>
+        <p:nvSpPr>
+          <p:cNvPr id="10" name="Rounded Rectangle 9"/>
+          <p:cNvSpPr/>
+          <p:nvPr/>
+        </p:nvSpPr>
+        <p:spPr>
+          <a:xfrm>
+            <a:off x="3429000" y="1828800"/>
+            <a:ext cx="2240280" cy="960120"/>
+          </a:xfrm>
+          <a:prstGeom prst="roundRect">
+            <a:avLst/>
+          </a:prstGeom>
+          <a:solidFill>
+            <a:srgbClr val="FFFFFF"/>
+          </a:solidFill>
+          <a:ln w="12700">
+            <a:solidFill>
+              <a:srgbClr val="C7DBD2"/>
+            </a:solidFill>
+          </a:ln>
+        </p:spPr>
+        <p:style>
+          <a:lnRef idx="1">
+            <a:schemeClr val="accent1"/>
+          </a:lnRef>
+          <a:fillRef idx="3">
+            <a:schemeClr val="accent1"/>
+          </a:fillRef>
+          <a:effectRef idx="2">
+            <a:schemeClr val="accent1"/>
+          </a:effectRef>
+          <a:fontRef idx="minor">
+            <a:schemeClr val="lt1"/>
+          </a:fontRef>
+        </p:style>
+        <p:txBody>
+          <a:bodyPr rtlCol="0" anchor="ctr"/>
+          <a:lstStyle/>
+          <a:p>
+            <a:pPr algn="ctr"/>
+          </a:p>
+        </p:txBody>
+      </p:sp>
+      <p:sp>
+        <p:nvSpPr>
+          <p:cNvPr id="11" name="TextBox 10"/>
+          <p:cNvSpPr txBox="1"/>
+          <p:nvPr/>
+        </p:nvSpPr>
+        <p:spPr>
+          <a:xfrm>
+            <a:off x="3566160" y="1965960"/>
+            <a:ext cx="1920240" cy="228600"/>
+          </a:xfrm>
+          <a:prstGeom prst="rect">
+            <a:avLst/>
+          </a:prstGeom>
+          <a:noFill/>
+        </p:spPr>
+        <p:txBody>
+          <a:bodyPr wrap="none" lIns="36576" rIns="36576" tIns="18288" bIns="18288" anchor="t">
+            <a:spAutoFit/>
+          </a:bodyPr>
+          <a:lstStyle/>
+          <a:p>
+            <a:pPr algn="ctr"/>
+            <a:r>
+              <a:rPr sz="1500" b="1">
+                <a:solidFill>
+                  <a:srgbClr val="08483A"/>
+                </a:solidFill>
+                <a:latin typeface="Aptos"/>
+              </a:rPr>
+              <a:t>Portfolio</a:t>
+            </a:r>
+          </a:p>
+        </p:txBody>
+      </p:sp>
+      <p:sp>
+        <p:nvSpPr>
+          <p:cNvPr id="12" name="TextBox 11"/>
+          <p:cNvSpPr txBox="1"/>
+          <p:nvPr/>
+        </p:nvSpPr>
+        <p:spPr>
+          <a:xfrm>
+            <a:off x="3593592" y="2276856"/>
+            <a:ext cx="1874519" cy="292608"/>
+          </a:xfrm>
+          <a:prstGeom prst="rect">
+            <a:avLst/>
+          </a:prstGeom>
+          <a:noFill/>
+        </p:spPr>
+        <p:txBody>
+          <a:bodyPr wrap="none" lIns="36576" rIns="36576" tIns="18288" bIns="18288" anchor="t">
+            <a:spAutoFit/>
+          </a:bodyPr>
+          <a:lstStyle/>
+          <a:p>
+            <a:pPr algn="ctr"/>
+            <a:r>
+              <a:rPr sz="1050" b="0">
+                <a:solidFill>
+                  <a:srgbClr val="586962"/>
+                </a:solidFill>
+                <a:latin typeface="Aptos"/>
+              </a:rPr>
+              <a:t>AAPL 5 shares, MSFT $800</a:t>
+            </a:r>
+          </a:p>
+        </p:txBody>
+      </p:sp>
+      <p:sp>
+        <p:nvSpPr>
+          <p:cNvPr id="13" name="TextBox 12"/>
+          <p:cNvSpPr txBox="1"/>
+          <p:nvPr/>
+        </p:nvSpPr>
+        <p:spPr>
+          <a:xfrm>
+            <a:off x="5760720" y="2139696"/>
+            <a:ext cx="320040" cy="228600"/>
+          </a:xfrm>
+          <a:prstGeom prst="rect">
+            <a:avLst/>
+          </a:prstGeom>
+          <a:noFill/>
+        </p:spPr>
+        <p:txBody>
+          <a:bodyPr wrap="none" lIns="36576" rIns="36576" tIns="18288" bIns="18288" anchor="t">
+            <a:spAutoFit/>
+          </a:bodyPr>
+          <a:lstStyle/>
+          <a:p>
+            <a:pPr algn="ctr"/>
+            <a:r>
+              <a:rPr sz="1800" b="1">
+                <a:solidFill>
+                  <a:srgbClr val="128466"/>
+                </a:solidFill>
+                <a:latin typeface="Aptos"/>
+              </a:rPr>
+              <a:t>-&gt;</a:t>
+            </a:r>
+          </a:p>
+        </p:txBody>
+      </p:sp>
+      <p:sp>
+        <p:nvSpPr>
+          <p:cNvPr id="14" name="Rounded Rectangle 13"/>
+          <p:cNvSpPr/>
+          <p:nvPr/>
+        </p:nvSpPr>
+        <p:spPr>
+          <a:xfrm>
+            <a:off x="6172200" y="1828800"/>
+            <a:ext cx="2240280" cy="960120"/>
+          </a:xfrm>
+          <a:prstGeom prst="roundRect">
+            <a:avLst/>
+          </a:prstGeom>
+          <a:solidFill>
+            <a:srgbClr val="FFFFFF"/>
+          </a:solidFill>
+          <a:ln w="12700">
+            <a:solidFill>
+              <a:srgbClr val="C7DBD2"/>
+            </a:solidFill>
+          </a:ln>
+        </p:spPr>
+        <p:style>
+          <a:lnRef idx="1">
+            <a:schemeClr val="accent1"/>
+          </a:lnRef>
+          <a:fillRef idx="3">
+            <a:schemeClr val="accent1"/>
+          </a:fillRef>
+          <a:effectRef idx="2">
+            <a:schemeClr val="accent1"/>
+          </a:effectRef>
+          <a:fontRef idx="minor">
+            <a:schemeClr val="lt1"/>
+          </a:fontRef>
+        </p:style>
+        <p:txBody>
+          <a:bodyPr rtlCol="0" anchor="ctr"/>
+          <a:lstStyle/>
+          <a:p>
+            <a:pPr algn="ctr"/>
+          </a:p>
+        </p:txBody>
+      </p:sp>
+      <p:sp>
+        <p:nvSpPr>
+          <p:cNvPr id="15" name="TextBox 14"/>
+          <p:cNvSpPr txBox="1"/>
+          <p:nvPr/>
+        </p:nvSpPr>
+        <p:spPr>
+          <a:xfrm>
+            <a:off x="6309360" y="1965960"/>
+            <a:ext cx="1920240" cy="228600"/>
+          </a:xfrm>
+          <a:prstGeom prst="rect">
+            <a:avLst/>
+          </a:prstGeom>
+          <a:noFill/>
+        </p:spPr>
+        <p:txBody>
+          <a:bodyPr wrap="none" lIns="36576" rIns="36576" tIns="18288" bIns="18288" anchor="t">
+            <a:spAutoFit/>
+          </a:bodyPr>
+          <a:lstStyle/>
+          <a:p>
+            <a:pPr algn="ctr"/>
+            <a:r>
+              <a:rPr sz="1500" b="1">
+                <a:solidFill>
+                  <a:srgbClr val="08483A"/>
+                </a:solidFill>
+                <a:latin typeface="Aptos"/>
+              </a:rPr>
+              <a:t>Agents</a:t>
+            </a:r>
+          </a:p>
+        </p:txBody>
+      </p:sp>
+      <p:sp>
+        <p:nvSpPr>
+          <p:cNvPr id="16" name="TextBox 15"/>
+          <p:cNvSpPr txBox="1"/>
+          <p:nvPr/>
+        </p:nvSpPr>
+        <p:spPr>
+          <a:xfrm>
+            <a:off x="6336792" y="2276856"/>
+            <a:ext cx="1874519" cy="292608"/>
+          </a:xfrm>
+          <a:prstGeom prst="rect">
+            <a:avLst/>
+          </a:prstGeom>
+          <a:noFill/>
+        </p:spPr>
+        <p:txBody>
+          <a:bodyPr wrap="none" lIns="36576" rIns="36576" tIns="18288" bIns="18288" anchor="t">
+            <a:spAutoFit/>
+          </a:bodyPr>
+          <a:lstStyle/>
+          <a:p>
+            <a:pPr algn="ctr"/>
+            <a:r>
+              <a:rPr sz="1050" b="0">
+                <a:solidFill>
+                  <a:srgbClr val="586962"/>
+                </a:solidFill>
+                <a:latin typeface="Aptos"/>
+              </a:rPr>
+              <a:t>RAG + Sentiment + Risk + Forecast</a:t>
+            </a:r>
+          </a:p>
+        </p:txBody>
+      </p:sp>
+      <p:sp>
+        <p:nvSpPr>
+          <p:cNvPr id="17" name="TextBox 16"/>
+          <p:cNvSpPr txBox="1"/>
+          <p:nvPr/>
+        </p:nvSpPr>
+        <p:spPr>
+          <a:xfrm>
+            <a:off x="8503920" y="2139696"/>
+            <a:ext cx="320040" cy="228600"/>
+          </a:xfrm>
+          <a:prstGeom prst="rect">
+            <a:avLst/>
+          </a:prstGeom>
+          <a:noFill/>
+        </p:spPr>
+        <p:txBody>
+          <a:bodyPr wrap="none" lIns="36576" rIns="36576" tIns="18288" bIns="18288" anchor="t">
+            <a:spAutoFit/>
+          </a:bodyPr>
+          <a:lstStyle/>
+          <a:p>
+            <a:pPr algn="ctr"/>
+            <a:r>
+              <a:rPr sz="1800" b="1">
+                <a:solidFill>
+                  <a:srgbClr val="128466"/>
+                </a:solidFill>
+                <a:latin typeface="Aptos"/>
+              </a:rPr>
+              <a:t>-&gt;</a:t>
+            </a:r>
+          </a:p>
+        </p:txBody>
+      </p:sp>
+      <p:sp>
+        <p:nvSpPr>
+          <p:cNvPr id="18" name="Rounded Rectangle 17"/>
+          <p:cNvSpPr/>
+          <p:nvPr/>
+        </p:nvSpPr>
+        <p:spPr>
+          <a:xfrm>
+            <a:off x="8915400" y="1828800"/>
+            <a:ext cx="2240280" cy="960120"/>
+          </a:xfrm>
+          <a:prstGeom prst="roundRect">
+            <a:avLst/>
+          </a:prstGeom>
+          <a:solidFill>
+            <a:srgbClr val="FFFFFF"/>
+          </a:solidFill>
+          <a:ln w="12700">
+            <a:solidFill>
+              <a:srgbClr val="C7DBD2"/>
+            </a:solidFill>
+          </a:ln>
+        </p:spPr>
+        <p:style>
+          <a:lnRef idx="1">
+            <a:schemeClr val="accent1"/>
+          </a:lnRef>
+          <a:fillRef idx="3">
+            <a:schemeClr val="accent1"/>
+          </a:fillRef>
+          <a:effectRef idx="2">
+            <a:schemeClr val="accent1"/>
+          </a:effectRef>
+          <a:fontRef idx="minor">
+            <a:schemeClr val="lt1"/>
+          </a:fontRef>
+        </p:style>
+        <p:txBody>
+          <a:bodyPr rtlCol="0" anchor="ctr"/>
+          <a:lstStyle/>
+          <a:p>
+            <a:pPr algn="ctr"/>
+          </a:p>
+        </p:txBody>
+      </p:sp>
+      <p:sp>
+        <p:nvSpPr>
+          <p:cNvPr id="19" name="TextBox 18"/>
+          <p:cNvSpPr txBox="1"/>
+          <p:nvPr/>
+        </p:nvSpPr>
+        <p:spPr>
+          <a:xfrm>
+            <a:off x="9052560" y="1965960"/>
+            <a:ext cx="1920240" cy="228600"/>
+          </a:xfrm>
+          <a:prstGeom prst="rect">
+            <a:avLst/>
+          </a:prstGeom>
+          <a:noFill/>
+        </p:spPr>
+        <p:txBody>
+          <a:bodyPr wrap="none" lIns="36576" rIns="36576" tIns="18288" bIns="18288" anchor="t">
+            <a:spAutoFit/>
+          </a:bodyPr>
+          <a:lstStyle/>
+          <a:p>
+            <a:pPr algn="ctr"/>
+            <a:r>
+              <a:rPr sz="1500" b="1">
+                <a:solidFill>
+                  <a:srgbClr val="08483A"/>
+                </a:solidFill>
+                <a:latin typeface="Aptos"/>
+              </a:rPr>
+              <a:t>Plan</a:t>
+            </a:r>
+          </a:p>
+        </p:txBody>
+      </p:sp>
+      <p:sp>
+        <p:nvSpPr>
+          <p:cNvPr id="20" name="TextBox 19"/>
+          <p:cNvSpPr txBox="1"/>
+          <p:nvPr/>
+        </p:nvSpPr>
+        <p:spPr>
+          <a:xfrm>
+            <a:off x="9079992" y="2276856"/>
+            <a:ext cx="1874519" cy="292608"/>
+          </a:xfrm>
+          <a:prstGeom prst="rect">
+            <a:avLst/>
+          </a:prstGeom>
+          <a:noFill/>
+        </p:spPr>
+        <p:txBody>
+          <a:bodyPr wrap="none" lIns="36576" rIns="36576" tIns="18288" bIns="18288" anchor="t">
+            <a:spAutoFit/>
+          </a:bodyPr>
+          <a:lstStyle/>
+          <a:p>
+            <a:pPr algn="ctr"/>
+            <a:r>
+              <a:rPr sz="1050" b="0">
+                <a:solidFill>
+                  <a:srgbClr val="586962"/>
+                </a:solidFill>
+                <a:latin typeface="Aptos"/>
+              </a:rPr>
+              <a:t>Reserve + staged allocation</a:t>
+            </a:r>
+          </a:p>
+        </p:txBody>
+      </p:sp>
+      <p:sp>
+        <p:nvSpPr>
+          <p:cNvPr id="21" name="Rounded Rectangle 20"/>
+          <p:cNvSpPr/>
+          <p:nvPr/>
+        </p:nvSpPr>
+        <p:spPr>
+          <a:xfrm>
+            <a:off x="685800" y="3154680"/>
+            <a:ext cx="4663440" cy="2057400"/>
+          </a:xfrm>
+          <a:prstGeom prst="roundRect">
+            <a:avLst/>
+          </a:prstGeom>
+          <a:solidFill>
+            <a:srgbClr val="EEF7F3"/>
+          </a:solidFill>
+          <a:ln w="12700">
+            <a:solidFill>
+              <a:srgbClr val="C7DBD2"/>
+            </a:solidFill>
+          </a:ln>
+        </p:spPr>
+        <p:style>
+          <a:lnRef idx="1">
+            <a:schemeClr val="accent1"/>
+          </a:lnRef>
+          <a:fillRef idx="3">
+            <a:schemeClr val="accent1"/>
+          </a:fillRef>
+          <a:effectRef idx="2">
+            <a:schemeClr val="accent1"/>
+          </a:effectRef>
+          <a:fontRef idx="minor">
+            <a:schemeClr val="lt1"/>
+          </a:fontRef>
+        </p:style>
+        <p:txBody>
+          <a:bodyPr rtlCol="0" anchor="ctr"/>
+          <a:lstStyle/>
+          <a:p>
+            <a:pPr algn="ctr"/>
+          </a:p>
+        </p:txBody>
+      </p:sp>
+      <p:sp>
+        <p:nvSpPr>
+          <p:cNvPr id="22" name="TextBox 21"/>
+          <p:cNvSpPr txBox="1"/>
+          <p:nvPr/>
+        </p:nvSpPr>
+        <p:spPr>
+          <a:xfrm>
+            <a:off x="914400" y="3364992"/>
+            <a:ext cx="3200400" cy="274320"/>
+          </a:xfrm>
+          <a:prstGeom prst="rect">
+            <a:avLst/>
+          </a:prstGeom>
+          <a:noFill/>
+        </p:spPr>
+        <p:txBody>
+          <a:bodyPr wrap="none" lIns="36576" rIns="36576" tIns="18288" bIns="18288" anchor="t">
+            <a:spAutoFit/>
+          </a:bodyPr>
+          <a:lstStyle/>
+          <a:p>
+            <a:pPr algn="l"/>
+            <a:r>
+              <a:rPr sz="1600" b="1">
+                <a:solidFill>
+                  <a:srgbClr val="12201C"/>
+                </a:solidFill>
+                <a:latin typeface="Aptos"/>
+              </a:rPr>
+              <a:t>User-facing guardrails</a:t>
+            </a:r>
+          </a:p>
+        </p:txBody>
+      </p:sp>
+      <p:sp>
+        <p:nvSpPr>
+          <p:cNvPr id="23" name="TextBox 22"/>
+          <p:cNvSpPr txBox="1"/>
+          <p:nvPr/>
+        </p:nvSpPr>
+        <p:spPr>
+          <a:xfrm>
+            <a:off x="914400" y="3730752"/>
+            <a:ext cx="4069080" cy="1188720"/>
+          </a:xfrm>
+          <a:prstGeom prst="rect">
+            <a:avLst/>
+          </a:prstGeom>
+          <a:noFill/>
+        </p:spPr>
+        <p:txBody>
+          <a:bodyPr wrap="none" lIns="73152" rIns="36576" tIns="36576" bIns="36576">
+            <a:spAutoFit/>
+          </a:bodyPr>
+          <a:lstStyle/>
+          <a:p>
+            <a:pPr>
+              <a:spcAft>
+                <a:spcPts val="800"/>
+              </a:spcAft>
+              <a:defRPr sz="1350">
+                <a:solidFill>
+                  <a:srgbClr val="12201C"/>
+                </a:solidFill>
+                <a:latin typeface="Aptos"/>
+              </a:defRPr>
+            </a:pPr>
+            <a:r>
+              <a:t>No full-budget single-stock recommendation.</a:t>
+            </a:r>
+          </a:p>
+          <a:p>
+            <a:pPr>
+              <a:spcAft>
+                <a:spcPts val="800"/>
+              </a:spcAft>
+              <a:defRPr sz="1350">
+                <a:solidFill>
+                  <a:srgbClr val="12201C"/>
+                </a:solidFill>
+                <a:latin typeface="Aptos"/>
+              </a:defRPr>
+            </a:pPr>
+            <a:r>
+              <a:t>Single-stock Buy allocation capped by risk profile.</a:t>
+            </a:r>
+          </a:p>
+          <a:p>
+            <a:pPr>
+              <a:spcAft>
+                <a:spcPts val="800"/>
+              </a:spcAft>
+              <a:defRPr sz="1350">
+                <a:solidFill>
+                  <a:srgbClr val="12201C"/>
+                </a:solidFill>
+                <a:latin typeface="Aptos"/>
+              </a:defRPr>
+            </a:pPr>
+            <a:r>
+              <a:t>Hold-level signals become Watch actions, not Buy instructions.</a:t>
+            </a:r>
+          </a:p>
+          <a:p>
+            <a:pPr>
+              <a:spcAft>
+                <a:spcPts val="800"/>
+              </a:spcAft>
+              <a:defRPr sz="1350">
+                <a:solidFill>
+                  <a:srgbClr val="12201C"/>
+                </a:solidFill>
+                <a:latin typeface="Aptos"/>
+              </a:defRPr>
+            </a:pPr>
+            <a:r>
+              <a:t>Portfolio overlap warning if a suggested ticker is already owned.</a:t>
+            </a:r>
+          </a:p>
+        </p:txBody>
+      </p:sp>
+      <p:sp>
+        <p:nvSpPr>
+          <p:cNvPr id="24" name="Rounded Rectangle 23"/>
+          <p:cNvSpPr/>
+          <p:nvPr/>
+        </p:nvSpPr>
+        <p:spPr>
+          <a:xfrm>
+            <a:off x="5623560" y="3154680"/>
+            <a:ext cx="4663440" cy="2057400"/>
+          </a:xfrm>
+          <a:prstGeom prst="roundRect">
+            <a:avLst/>
+          </a:prstGeom>
+          <a:solidFill>
+            <a:srgbClr val="FFFFFF"/>
+          </a:solidFill>
+          <a:ln w="12700">
+            <a:solidFill>
+              <a:srgbClr val="C7DBD2"/>
+            </a:solidFill>
+          </a:ln>
+        </p:spPr>
+        <p:style>
+          <a:lnRef idx="1">
+            <a:schemeClr val="accent1"/>
+          </a:lnRef>
+          <a:fillRef idx="3">
+            <a:schemeClr val="accent1"/>
+          </a:fillRef>
+          <a:effectRef idx="2">
+            <a:schemeClr val="accent1"/>
+          </a:effectRef>
+          <a:fontRef idx="minor">
+            <a:schemeClr val="lt1"/>
+          </a:fontRef>
+        </p:style>
+        <p:txBody>
+          <a:bodyPr rtlCol="0" anchor="ctr"/>
+          <a:lstStyle/>
+          <a:p>
+            <a:pPr algn="ctr"/>
+          </a:p>
+        </p:txBody>
+      </p:sp>
+      <p:sp>
+        <p:nvSpPr>
+          <p:cNvPr id="25" name="TextBox 24"/>
+          <p:cNvSpPr txBox="1"/>
+          <p:nvPr/>
+        </p:nvSpPr>
+        <p:spPr>
+          <a:xfrm>
+            <a:off x="5852160" y="3364992"/>
+            <a:ext cx="3017520" cy="274320"/>
+          </a:xfrm>
+          <a:prstGeom prst="rect">
+            <a:avLst/>
+          </a:prstGeom>
+          <a:noFill/>
+        </p:spPr>
+        <p:txBody>
+          <a:bodyPr wrap="none" lIns="36576" rIns="36576" tIns="18288" bIns="18288" anchor="t">
+            <a:spAutoFit/>
+          </a:bodyPr>
+          <a:lstStyle/>
+          <a:p>
+            <a:pPr algn="l"/>
+            <a:r>
+              <a:rPr sz="1600" b="1">
+                <a:solidFill>
+                  <a:srgbClr val="12201C"/>
+                </a:solidFill>
+                <a:latin typeface="Aptos"/>
+              </a:rPr>
+              <a:t>Measured performance</a:t>
+            </a:r>
+          </a:p>
+        </p:txBody>
+      </p:sp>
+      <p:sp>
+        <p:nvSpPr>
+          <p:cNvPr id="26" name="TextBox 25"/>
+          <p:cNvSpPr txBox="1"/>
+          <p:nvPr/>
+        </p:nvSpPr>
+        <p:spPr>
+          <a:xfrm>
+            <a:off x="5897880" y="3767328"/>
+            <a:ext cx="2194560" cy="411480"/>
+          </a:xfrm>
+          <a:prstGeom prst="rect">
+            <a:avLst/>
+          </a:prstGeom>
+          <a:noFill/>
+        </p:spPr>
+        <p:txBody>
+          <a:bodyPr wrap="none" lIns="36576" rIns="36576" tIns="18288" bIns="18288" anchor="t">
+            <a:spAutoFit/>
+          </a:bodyPr>
+          <a:lstStyle/>
+          <a:p>
+            <a:pPr algn="l"/>
+            <a:r>
+              <a:rPr sz="2600" b="1">
+                <a:solidFill>
+                  <a:srgbClr val="08483A"/>
+                </a:solidFill>
+                <a:latin typeface="Aptos"/>
+              </a:rPr>
+              <a:t>8.8s -&gt; 2.0s</a:t>
+            </a:r>
+          </a:p>
+        </p:txBody>
+      </p:sp>
+      <p:sp>
+        <p:nvSpPr>
+          <p:cNvPr id="27" name="TextBox 26"/>
+          <p:cNvSpPr txBox="1"/>
+          <p:nvPr/>
+        </p:nvSpPr>
+        <p:spPr>
+          <a:xfrm>
+            <a:off x="5925312" y="4187952"/>
+            <a:ext cx="2926080" cy="228600"/>
+          </a:xfrm>
+          <a:prstGeom prst="rect">
+            <a:avLst/>
+          </a:prstGeom>
+          <a:noFill/>
+        </p:spPr>
+        <p:txBody>
+          <a:bodyPr wrap="none" lIns="36576" rIns="36576" tIns="18288" bIns="18288" anchor="t">
+            <a:spAutoFit/>
+          </a:bodyPr>
+          <a:lstStyle/>
+          <a:p>
+            <a:pPr algn="l"/>
+            <a:r>
+              <a:rPr sz="1150" b="0">
+                <a:solidFill>
+                  <a:srgbClr val="586962"/>
+                </a:solidFill>
+                <a:latin typeface="Aptos"/>
+              </a:rPr>
+              <a:t>First local Ask run after optimization</a:t>
+            </a:r>
+          </a:p>
+        </p:txBody>
+      </p:sp>
+      <p:sp>
+        <p:nvSpPr>
+          <p:cNvPr id="28" name="TextBox 27"/>
+          <p:cNvSpPr txBox="1"/>
+          <p:nvPr/>
+        </p:nvSpPr>
+        <p:spPr>
+          <a:xfrm>
+            <a:off x="8183879" y="3767328"/>
+            <a:ext cx="1737360" cy="411480"/>
+          </a:xfrm>
+          <a:prstGeom prst="rect">
+            <a:avLst/>
+          </a:prstGeom>
+          <a:noFill/>
+        </p:spPr>
+        <p:txBody>
+          <a:bodyPr wrap="none" lIns="36576" rIns="36576" tIns="18288" bIns="18288" anchor="t">
+            <a:spAutoFit/>
+          </a:bodyPr>
+          <a:lstStyle/>
+          <a:p>
+            <a:pPr algn="l"/>
+            <a:r>
+              <a:rPr sz="2400" b="1">
+                <a:solidFill>
+                  <a:srgbClr val="2B5E94"/>
+                </a:solidFill>
+                <a:latin typeface="Aptos"/>
+              </a:rPr>
+              <a:t>&lt; 1s cached</a:t>
+            </a:r>
+          </a:p>
+        </p:txBody>
+      </p:sp>
+      <p:sp>
+        <p:nvSpPr>
+          <p:cNvPr id="29" name="TextBox 28"/>
+          <p:cNvSpPr txBox="1"/>
+          <p:nvPr/>
+        </p:nvSpPr>
+        <p:spPr>
+          <a:xfrm>
+            <a:off x="8229600" y="4187952"/>
+            <a:ext cx="1645920" cy="228600"/>
+          </a:xfrm>
+          <a:prstGeom prst="rect">
+            <a:avLst/>
+          </a:prstGeom>
+          <a:noFill/>
+        </p:spPr>
+        <p:txBody>
+          <a:bodyPr wrap="none" lIns="36576" rIns="36576" tIns="18288" bIns="18288" anchor="t">
+            <a:spAutoFit/>
+          </a:bodyPr>
+          <a:lstStyle/>
+          <a:p>
+            <a:pPr algn="l"/>
+            <a:r>
+              <a:rPr sz="1150" b="0">
+                <a:solidFill>
+                  <a:srgbClr val="586962"/>
+                </a:solidFill>
+                <a:latin typeface="Aptos"/>
+              </a:rPr>
+              <a:t>Repeated warm path</a:t>
+            </a:r>
+          </a:p>
+        </p:txBody>
+      </p:sp>
+      <p:sp>
+        <p:nvSpPr>
+          <p:cNvPr id="30" name="TextBox 29"/>
+          <p:cNvSpPr txBox="1"/>
+          <p:nvPr/>
+        </p:nvSpPr>
+        <p:spPr>
+          <a:xfrm>
+            <a:off x="5870448" y="4526280"/>
+            <a:ext cx="3931920" cy="548640"/>
+          </a:xfrm>
+          <a:prstGeom prst="rect">
+            <a:avLst/>
+          </a:prstGeom>
+          <a:noFill/>
+        </p:spPr>
+        <p:txBody>
+          <a:bodyPr wrap="none" lIns="73152" rIns="36576" tIns="36576" bIns="36576">
+            <a:spAutoFit/>
+          </a:bodyPr>
+          <a:lstStyle/>
+          <a:p>
+            <a:pPr>
+              <a:spcAft>
+                <a:spcPts val="800"/>
+              </a:spcAft>
+              <a:defRPr sz="1250">
+                <a:solidFill>
+                  <a:srgbClr val="586962"/>
+                </a:solidFill>
+                <a:latin typeface="Aptos"/>
+              </a:defRPr>
+            </a:pPr>
+            <a:r>
+              <a:t>Cached OrchestratorAgent and CSV data.</a:t>
+            </a:r>
+          </a:p>
+          <a:p>
+            <a:pPr>
+              <a:spcAft>
+                <a:spcPts val="800"/>
+              </a:spcAft>
+              <a:defRPr sz="1250">
+                <a:solidFill>
+                  <a:srgbClr val="586962"/>
+                </a:solidFill>
+                <a:latin typeface="Aptos"/>
+              </a:defRPr>
+            </a:pPr>
+            <a:r>
+              <a:t>Reduced Chroma rerank pool with FIE_VECTOR_CANDIDATES.</a:t>
+            </a:r>
+          </a:p>
+          <a:p>
+            <a:pPr>
+              <a:spcAft>
+                <a:spcPts val="800"/>
+              </a:spcAft>
+              <a:defRPr sz="1250">
+                <a:solidFill>
+                  <a:srgbClr val="586962"/>
+                </a:solidFill>
+                <a:latin typeface="Aptos"/>
+              </a:defRPr>
+            </a:pPr>
+            <a:r>
+              <a:t>Added per-agent timings in API response.</a:t>
+            </a:r>
+          </a:p>
+        </p:txBody>
+      </p:sp>
+      <p:sp>
+        <p:nvSpPr>
+          <p:cNvPr id="31" name="Rounded Rectangle 30"/>
+          <p:cNvSpPr/>
+          <p:nvPr/>
+        </p:nvSpPr>
+        <p:spPr>
+          <a:xfrm>
+            <a:off x="822960" y="5623560"/>
+            <a:ext cx="2057400" cy="310896"/>
+          </a:xfrm>
+          <a:prstGeom prst="roundRect">
+            <a:avLst/>
+          </a:prstGeom>
+          <a:solidFill>
+            <a:srgbClr val="E5EEF8"/>
+          </a:solidFill>
+          <a:ln w="12700">
+            <a:solidFill>
+              <a:srgbClr val="E5EEF8"/>
+            </a:solidFill>
+          </a:ln>
+        </p:spPr>
+        <p:style>
+          <a:lnRef idx="1">
+            <a:schemeClr val="accent1"/>
+          </a:lnRef>
+          <a:fillRef idx="3">
+            <a:schemeClr val="accent1"/>
+          </a:fillRef>
+          <a:effectRef idx="2">
+            <a:schemeClr val="accent1"/>
+          </a:effectRef>
+          <a:fontRef idx="minor">
+            <a:schemeClr val="lt1"/>
+          </a:fontRef>
+        </p:style>
+        <p:txBody>
+          <a:bodyPr rtlCol="0" anchor="ctr"/>
+          <a:lstStyle/>
+          <a:p>
+            <a:pPr algn="ctr"/>
+          </a:p>
+        </p:txBody>
+      </p:sp>
+      <p:sp>
+        <p:nvSpPr>
+          <p:cNvPr id="32" name="TextBox 31"/>
+          <p:cNvSpPr txBox="1"/>
+          <p:nvPr/>
+        </p:nvSpPr>
+        <p:spPr>
+          <a:xfrm>
+            <a:off x="896112" y="5687568"/>
+            <a:ext cx="1911095" cy="146304"/>
+          </a:xfrm>
+          <a:prstGeom prst="rect">
+            <a:avLst/>
+          </a:prstGeom>
+          <a:noFill/>
+        </p:spPr>
+        <p:txBody>
+          <a:bodyPr wrap="none" lIns="36576" rIns="36576" tIns="18288" bIns="18288" anchor="t">
+            <a:spAutoFit/>
+          </a:bodyPr>
+          <a:lstStyle/>
+          <a:p>
+            <a:pPr algn="ctr"/>
+            <a:r>
+              <a:rPr sz="1000" b="1">
+                <a:solidFill>
+                  <a:srgbClr val="2B5E94"/>
+                </a:solidFill>
+                <a:latin typeface="Aptos"/>
+              </a:rPr>
+              <a:t>agents/orchestrator_agent.py</a:t>
+            </a:r>
+          </a:p>
+        </p:txBody>
+      </p:sp>
+      <p:sp>
+        <p:nvSpPr>
+          <p:cNvPr id="33" name="Rounded Rectangle 32"/>
+          <p:cNvSpPr/>
+          <p:nvPr/>
+        </p:nvSpPr>
+        <p:spPr>
+          <a:xfrm>
+            <a:off x="3017520" y="5623560"/>
+            <a:ext cx="1691640" cy="310896"/>
+          </a:xfrm>
+          <a:prstGeom prst="roundRect">
+            <a:avLst/>
+          </a:prstGeom>
+          <a:solidFill>
+            <a:srgbClr val="E5EEF8"/>
+          </a:solidFill>
+          <a:ln w="12700">
+            <a:solidFill>
+              <a:srgbClr val="E5EEF8"/>
+            </a:solidFill>
+          </a:ln>
+        </p:spPr>
+        <p:style>
+          <a:lnRef idx="1">
+            <a:schemeClr val="accent1"/>
+          </a:lnRef>
+          <a:fillRef idx="3">
+            <a:schemeClr val="accent1"/>
+          </a:fillRef>
+          <a:effectRef idx="2">
+            <a:schemeClr val="accent1"/>
+          </a:effectRef>
+          <a:fontRef idx="minor">
+            <a:schemeClr val="lt1"/>
+          </a:fontRef>
+        </p:style>
+        <p:txBody>
+          <a:bodyPr rtlCol="0" anchor="ctr"/>
+          <a:lstStyle/>
+          <a:p>
+            <a:pPr algn="ctr"/>
+          </a:p>
+        </p:txBody>
+      </p:sp>
+      <p:sp>
+        <p:nvSpPr>
+          <p:cNvPr id="34" name="TextBox 33"/>
+          <p:cNvSpPr txBox="1"/>
+          <p:nvPr/>
+        </p:nvSpPr>
+        <p:spPr>
+          <a:xfrm>
+            <a:off x="3090672" y="5687568"/>
+            <a:ext cx="1545336" cy="146304"/>
+          </a:xfrm>
+          <a:prstGeom prst="rect">
+            <a:avLst/>
+          </a:prstGeom>
+          <a:noFill/>
+        </p:spPr>
+        <p:txBody>
+          <a:bodyPr wrap="none" lIns="36576" rIns="36576" tIns="18288" bIns="18288" anchor="t">
+            <a:spAutoFit/>
+          </a:bodyPr>
+          <a:lstStyle/>
+          <a:p>
+            <a:pPr algn="ctr"/>
+            <a:r>
+              <a:rPr sz="1000" b="1">
+                <a:solidFill>
+                  <a:srgbClr val="2B5E94"/>
+                </a:solidFill>
+                <a:latin typeface="Aptos"/>
+              </a:rPr>
+              <a:t>rag_layer/retriever.py</a:t>
+            </a:r>
+          </a:p>
+        </p:txBody>
+      </p:sp>
+      <p:sp>
+        <p:nvSpPr>
+          <p:cNvPr id="35" name="Rounded Rectangle 34"/>
+          <p:cNvSpPr/>
+          <p:nvPr/>
+        </p:nvSpPr>
+        <p:spPr>
+          <a:xfrm>
+            <a:off x="4892040" y="5623560"/>
+            <a:ext cx="1325880" cy="310896"/>
+          </a:xfrm>
+          <a:prstGeom prst="roundRect">
+            <a:avLst/>
+          </a:prstGeom>
+          <a:solidFill>
+            <a:srgbClr val="EEF7F3"/>
+          </a:solidFill>
+          <a:ln w="12700">
+            <a:solidFill>
+              <a:srgbClr val="EEF7F3"/>
+            </a:solidFill>
+          </a:ln>
+        </p:spPr>
+        <p:style>
+          <a:lnRef idx="1">
+            <a:schemeClr val="accent1"/>
+          </a:lnRef>
+          <a:fillRef idx="3">
+            <a:schemeClr val="accent1"/>
+          </a:fillRef>
+          <a:effectRef idx="2">
+            <a:schemeClr val="accent1"/>
+          </a:effectRef>
+          <a:fontRef idx="minor">
+            <a:schemeClr val="lt1"/>
+          </a:fontRef>
+        </p:style>
+        <p:txBody>
+          <a:bodyPr rtlCol="0" anchor="ctr"/>
+          <a:lstStyle/>
+          <a:p>
+            <a:pPr algn="ctr"/>
+          </a:p>
+        </p:txBody>
+      </p:sp>
+      <p:sp>
+        <p:nvSpPr>
+          <p:cNvPr id="36" name="TextBox 35"/>
+          <p:cNvSpPr txBox="1"/>
+          <p:nvPr/>
+        </p:nvSpPr>
+        <p:spPr>
+          <a:xfrm>
+            <a:off x="4965192" y="5687568"/>
+            <a:ext cx="1179576" cy="146304"/>
+          </a:xfrm>
+          <a:prstGeom prst="rect">
+            <a:avLst/>
+          </a:prstGeom>
+          <a:noFill/>
+        </p:spPr>
+        <p:txBody>
+          <a:bodyPr wrap="none" lIns="36576" rIns="36576" tIns="18288" bIns="18288" anchor="t">
+            <a:spAutoFit/>
+          </a:bodyPr>
+          <a:lstStyle/>
+          <a:p>
+            <a:pPr algn="ctr"/>
+            <a:r>
+              <a:rPr sz="1000" b="1">
+                <a:solidFill>
+                  <a:srgbClr val="08483A"/>
+                </a:solidFill>
+                <a:latin typeface="Aptos"/>
+              </a:rPr>
+              <a:t>tests: 23 passed</a:t>
+            </a:r>
+          </a:p>
+        </p:txBody>
+      </p:sp>
+      <p:sp>
+        <p:nvSpPr>
+          <p:cNvPr id="37" name="Rounded Rectangle 36"/>
+          <p:cNvSpPr/>
+          <p:nvPr/>
+        </p:nvSpPr>
+        <p:spPr>
+          <a:xfrm>
+            <a:off x="6400800" y="5623560"/>
+            <a:ext cx="2194560" cy="310896"/>
+          </a:xfrm>
+          <a:prstGeom prst="roundRect">
+            <a:avLst/>
+          </a:prstGeom>
+          <a:solidFill>
+            <a:srgbClr val="EEF7F3"/>
+          </a:solidFill>
+          <a:ln w="12700">
+            <a:solidFill>
+              <a:srgbClr val="EEF7F3"/>
+            </a:solidFill>
+          </a:ln>
+        </p:spPr>
+        <p:style>
+          <a:lnRef idx="1">
+            <a:schemeClr val="accent1"/>
+          </a:lnRef>
+          <a:fillRef idx="3">
+            <a:schemeClr val="accent1"/>
+          </a:fillRef>
+          <a:effectRef idx="2">
+            <a:schemeClr val="accent1"/>
+          </a:effectRef>
+          <a:fontRef idx="minor">
+            <a:schemeClr val="lt1"/>
+          </a:fontRef>
+        </p:style>
+        <p:txBody>
+          <a:bodyPr rtlCol="0" anchor="ctr"/>
+          <a:lstStyle/>
+          <a:p>
+            <a:pPr algn="ctr"/>
+          </a:p>
+        </p:txBody>
+      </p:sp>
+      <p:sp>
+        <p:nvSpPr>
+          <p:cNvPr id="38" name="TextBox 37"/>
+          <p:cNvSpPr txBox="1"/>
+          <p:nvPr/>
+        </p:nvSpPr>
+        <p:spPr>
+          <a:xfrm>
+            <a:off x="6473952" y="5687568"/>
+            <a:ext cx="2048255" cy="146304"/>
+          </a:xfrm>
+          <a:prstGeom prst="rect">
+            <a:avLst/>
+          </a:prstGeom>
+          <a:noFill/>
+        </p:spPr>
+        <p:txBody>
+          <a:bodyPr wrap="none" lIns="36576" rIns="36576" tIns="18288" bIns="18288" anchor="t">
+            <a:spAutoFit/>
+          </a:bodyPr>
+          <a:lstStyle/>
+          <a:p>
+            <a:pPr algn="ctr"/>
+            <a:r>
+              <a:rPr sz="1000" b="1">
+                <a:solidFill>
+                  <a:srgbClr val="08483A"/>
+                </a:solidFill>
+                <a:latin typeface="Aptos"/>
+              </a:rPr>
+              <a:t>Render redeploy from GitHub</a:t>
+            </a:r>
+          </a:p>
+        </p:txBody>
+      </p:sp>
+    </p:spTree>
+  </p:cSld>
+  <p:clrMapOvr>
+    <a:masterClrMapping/>
+  </p:clrMapOvr>
 </p:sld>
 </file>
 

</xml_diff>